<commit_message>
Corregir E5 segun feedback del asesor: acuerdo vs kappa, meta 70%, segmentos y riesgos
Separa acuerdo bruto de kappa de Cohen (se confirmaron 3 casos donde el
resumen llamaba "acuerdo" a lo que en realidad era kappa, incluyendo uno
reconstruido y validado cruzando ground_truth_361_FINAL.xlsx contra
desacuerdos_jhomar_vs_hugo.xlsx: coincide exacto, 48/48 filas). Aclara
que el modelo v0 supero los baselines pero no alcanzo la meta
pre-registrada de 70% (66,9%). Agrega IC95% y n sin ponderar a la tabla
de segmentos. Corrige el umbral de kappa del riesgo 1 (0.70 -> 0.80,
igual al de la rubrica), pone fecha a los riesgos 2 y 3, y define que el
agente rechaza consultas de replica (antes solo una regla de evaluacion).
</commit_message>
<xml_diff>
--- a/E5_Equipo7_Portal_Gamarrino.pptx
+++ b/E5_Equipo7_Portal_Gamarrino.pptx
@@ -6840,427 +6840,7 @@
                 </a:solidFill>
                 <a:latin typeface="Arial Nova Light"/>
               </a:rPr>
-              <a:t>calidad</a:t>
-            </a:r>
-            <a:r>
-              <a:rPr sz="1300" dirty="0">
-                <a:solidFill>
-                  <a:schemeClr val="tx1">
-                    <a:lumMod val="65000"/>
-                    <a:lumOff val="35000"/>
-                  </a:schemeClr>
-                </a:solidFill>
-                <a:latin typeface="Arial Nova Light"/>
-              </a:rPr>
-              <a:t> </a:t>
-            </a:r>
-            <a:r>
-              <a:rPr sz="1300" dirty="0" err="1">
-                <a:solidFill>
-                  <a:schemeClr val="tx1">
-                    <a:lumMod val="65000"/>
-                    <a:lumOff val="35000"/>
-                  </a:schemeClr>
-                </a:solidFill>
-                <a:latin typeface="Arial Nova Light"/>
-              </a:rPr>
-              <a:t>por</a:t>
-            </a:r>
-            <a:r>
-              <a:rPr sz="1300" dirty="0">
-                <a:solidFill>
-                  <a:schemeClr val="tx1">
-                    <a:lumMod val="65000"/>
-                    <a:lumOff val="35000"/>
-                  </a:schemeClr>
-                </a:solidFill>
-                <a:latin typeface="Arial Nova Light"/>
-              </a:rPr>
-              <a:t> </a:t>
-            </a:r>
-            <a:r>
-              <a:rPr sz="1300" dirty="0" err="1">
-                <a:solidFill>
-                  <a:schemeClr val="tx1">
-                    <a:lumMod val="65000"/>
-                    <a:lumOff val="35000"/>
-                  </a:schemeClr>
-                </a:solidFill>
-                <a:latin typeface="Arial Nova Light"/>
-              </a:rPr>
-              <a:t>etiquetado</a:t>
-            </a:r>
-            <a:r>
-              <a:rPr sz="1300" dirty="0">
-                <a:solidFill>
-                  <a:schemeClr val="tx1">
-                    <a:lumMod val="65000"/>
-                    <a:lumOff val="35000"/>
-                  </a:schemeClr>
-                </a:solidFill>
-                <a:latin typeface="Arial Nova Light"/>
-              </a:rPr>
-              <a:t> </a:t>
-            </a:r>
-            <a:r>
-              <a:rPr sz="1300" dirty="0" err="1">
-                <a:solidFill>
-                  <a:schemeClr val="tx1">
-                    <a:lumMod val="65000"/>
-                    <a:lumOff val="35000"/>
-                  </a:schemeClr>
-                </a:solidFill>
-                <a:latin typeface="Arial Nova Light"/>
-              </a:rPr>
-              <a:t>humano</a:t>
-            </a:r>
-            <a:r>
-              <a:rPr sz="1300" dirty="0">
-                <a:solidFill>
-                  <a:schemeClr val="tx1">
-                    <a:lumMod val="65000"/>
-                    <a:lumOff val="35000"/>
-                  </a:schemeClr>
-                </a:solidFill>
-                <a:latin typeface="Arial Nova Light"/>
-              </a:rPr>
-              <a:t> (κ); LLM </a:t>
-            </a:r>
-            <a:r>
-              <a:rPr sz="1300" dirty="0" err="1">
-                <a:solidFill>
-                  <a:schemeClr val="tx1">
-                    <a:lumMod val="65000"/>
-                    <a:lumOff val="35000"/>
-                  </a:schemeClr>
-                </a:solidFill>
-                <a:latin typeface="Arial Nova Light"/>
-              </a:rPr>
-              <a:t>juez</a:t>
-            </a:r>
-            <a:r>
-              <a:rPr sz="1300" dirty="0">
-                <a:solidFill>
-                  <a:schemeClr val="tx1">
-                    <a:lumMod val="65000"/>
-                    <a:lumOff val="35000"/>
-                  </a:schemeClr>
-                </a:solidFill>
-                <a:latin typeface="Arial Nova Light"/>
-              </a:rPr>
-              <a:t> </a:t>
-            </a:r>
-            <a:r>
-              <a:rPr sz="1300" dirty="0" err="1">
-                <a:solidFill>
-                  <a:schemeClr val="tx1">
-                    <a:lumMod val="65000"/>
-                    <a:lumOff val="35000"/>
-                  </a:schemeClr>
-                </a:solidFill>
-                <a:latin typeface="Arial Nova Light"/>
-              </a:rPr>
-              <a:t>intentado</a:t>
-            </a:r>
-            <a:r>
-              <a:rPr sz="1300" dirty="0">
-                <a:solidFill>
-                  <a:schemeClr val="tx1">
-                    <a:lumMod val="65000"/>
-                    <a:lumOff val="35000"/>
-                  </a:schemeClr>
-                </a:solidFill>
-                <a:latin typeface="Arial Nova Light"/>
-              </a:rPr>
-              <a:t> y </a:t>
-            </a:r>
-            <a:r>
-              <a:rPr sz="1300" dirty="0" err="1">
-                <a:solidFill>
-                  <a:schemeClr val="tx1">
-                    <a:lumMod val="65000"/>
-                    <a:lumOff val="35000"/>
-                  </a:schemeClr>
-                </a:solidFill>
-                <a:latin typeface="Arial Nova Light"/>
-              </a:rPr>
-              <a:t>descartado</a:t>
-            </a:r>
-            <a:r>
-              <a:rPr sz="1300" dirty="0">
-                <a:solidFill>
-                  <a:schemeClr val="tx1">
-                    <a:lumMod val="65000"/>
-                    <a:lumOff val="35000"/>
-                  </a:schemeClr>
-                </a:solidFill>
-                <a:latin typeface="Arial Nova Light"/>
-              </a:rPr>
-              <a:t> (κ=0,515, no </a:t>
-            </a:r>
-            <a:r>
-              <a:rPr sz="1300" dirty="0" err="1">
-                <a:solidFill>
-                  <a:schemeClr val="tx1">
-                    <a:lumMod val="65000"/>
-                    <a:lumOff val="35000"/>
-                  </a:schemeClr>
-                </a:solidFill>
-                <a:latin typeface="Arial Nova Light"/>
-              </a:rPr>
-              <a:t>validó</a:t>
-            </a:r>
-            <a:r>
-              <a:rPr sz="1300" dirty="0">
-                <a:solidFill>
-                  <a:schemeClr val="tx1">
-                    <a:lumMod val="65000"/>
-                    <a:lumOff val="35000"/>
-                  </a:schemeClr>
-                </a:solidFill>
-                <a:latin typeface="Arial Nova Light"/>
-              </a:rPr>
-              <a:t>); </a:t>
-            </a:r>
-            <a:r>
-              <a:rPr sz="1300" dirty="0" err="1">
-                <a:solidFill>
-                  <a:schemeClr val="tx1">
-                    <a:lumMod val="65000"/>
-                    <a:lumOff val="35000"/>
-                  </a:schemeClr>
-                </a:solidFill>
-                <a:latin typeface="Arial Nova Light"/>
-              </a:rPr>
-              <a:t>costo</a:t>
-            </a:r>
-            <a:r>
-              <a:rPr sz="1300" dirty="0">
-                <a:solidFill>
-                  <a:schemeClr val="tx1">
-                    <a:lumMod val="65000"/>
-                    <a:lumOff val="35000"/>
-                  </a:schemeClr>
-                </a:solidFill>
-                <a:latin typeface="Arial Nova Light"/>
-              </a:rPr>
-              <a:t> &lt;$0,01 USD </a:t>
-            </a:r>
-            <a:r>
-              <a:rPr sz="1300" dirty="0" err="1">
-                <a:solidFill>
-                  <a:schemeClr val="tx1">
-                    <a:lumMod val="65000"/>
-                    <a:lumOff val="35000"/>
-                  </a:schemeClr>
-                </a:solidFill>
-                <a:latin typeface="Arial Nova Light"/>
-              </a:rPr>
-              <a:t>por</a:t>
-            </a:r>
-            <a:r>
-              <a:rPr sz="1300" dirty="0">
-                <a:solidFill>
-                  <a:schemeClr val="tx1">
-                    <a:lumMod val="65000"/>
-                    <a:lumOff val="35000"/>
-                  </a:schemeClr>
-                </a:solidFill>
-                <a:latin typeface="Arial Nova Light"/>
-              </a:rPr>
-              <a:t> </a:t>
-            </a:r>
-            <a:r>
-              <a:rPr sz="1300" dirty="0" err="1">
-                <a:solidFill>
-                  <a:schemeClr val="tx1">
-                    <a:lumMod val="65000"/>
-                    <a:lumOff val="35000"/>
-                  </a:schemeClr>
-                </a:solidFill>
-                <a:latin typeface="Arial Nova Light"/>
-              </a:rPr>
-              <a:t>esta</a:t>
-            </a:r>
-            <a:r>
-              <a:rPr sz="1300" dirty="0">
-                <a:solidFill>
-                  <a:schemeClr val="tx1">
-                    <a:lumMod val="65000"/>
-                    <a:lumOff val="35000"/>
-                  </a:schemeClr>
-                </a:solidFill>
-                <a:latin typeface="Arial Nova Light"/>
-              </a:rPr>
-              <a:t> </a:t>
-            </a:r>
-            <a:r>
-              <a:rPr sz="1300" dirty="0" err="1">
-                <a:solidFill>
-                  <a:schemeClr val="tx1">
-                    <a:lumMod val="65000"/>
-                    <a:lumOff val="35000"/>
-                  </a:schemeClr>
-                </a:solidFill>
-                <a:latin typeface="Arial Nova Light"/>
-              </a:rPr>
-              <a:t>prueba</a:t>
-            </a:r>
-            <a:r>
-              <a:rPr sz="1300" dirty="0">
-                <a:solidFill>
-                  <a:schemeClr val="tx1">
-                    <a:lumMod val="65000"/>
-                    <a:lumOff val="35000"/>
-                  </a:schemeClr>
-                </a:solidFill>
-                <a:latin typeface="Arial Nova Light"/>
-              </a:rPr>
-              <a:t>; </a:t>
-            </a:r>
-            <a:r>
-              <a:rPr sz="1300" dirty="0" err="1">
-                <a:solidFill>
-                  <a:schemeClr val="tx1">
-                    <a:lumMod val="65000"/>
-                    <a:lumOff val="35000"/>
-                  </a:schemeClr>
-                </a:solidFill>
-                <a:latin typeface="Arial Nova Light"/>
-              </a:rPr>
-              <a:t>latencia</a:t>
-            </a:r>
-            <a:r>
-              <a:rPr sz="1300" dirty="0">
-                <a:solidFill>
-                  <a:schemeClr val="tx1">
-                    <a:lumMod val="65000"/>
-                    <a:lumOff val="35000"/>
-                  </a:schemeClr>
-                </a:solidFill>
-                <a:latin typeface="Arial Nova Light"/>
-              </a:rPr>
-              <a:t> </a:t>
-            </a:r>
-            <a:r>
-              <a:rPr sz="1300" dirty="0" err="1">
-                <a:solidFill>
-                  <a:schemeClr val="tx1">
-                    <a:lumMod val="65000"/>
-                    <a:lumOff val="35000"/>
-                  </a:schemeClr>
-                </a:solidFill>
-                <a:latin typeface="Arial Nova Light"/>
-              </a:rPr>
-              <a:t>por</a:t>
-            </a:r>
-            <a:r>
-              <a:rPr sz="1300" dirty="0">
-                <a:solidFill>
-                  <a:schemeClr val="tx1">
-                    <a:lumMod val="65000"/>
-                    <a:lumOff val="35000"/>
-                  </a:schemeClr>
-                </a:solidFill>
-                <a:latin typeface="Arial Nova Light"/>
-              </a:rPr>
-              <a:t> </a:t>
-            </a:r>
-            <a:r>
-              <a:rPr sz="1300" dirty="0" err="1">
-                <a:solidFill>
-                  <a:schemeClr val="tx1">
-                    <a:lumMod val="65000"/>
-                    <a:lumOff val="35000"/>
-                  </a:schemeClr>
-                </a:solidFill>
-                <a:latin typeface="Arial Nova Light"/>
-              </a:rPr>
-              <a:t>medir</a:t>
-            </a:r>
-            <a:r>
-              <a:rPr sz="1300" dirty="0">
-                <a:solidFill>
-                  <a:schemeClr val="tx1">
-                    <a:lumMod val="65000"/>
-                    <a:lumOff val="35000"/>
-                  </a:schemeClr>
-                </a:solidFill>
-                <a:latin typeface="Arial Nova Light"/>
-              </a:rPr>
-              <a:t> (sin </a:t>
-            </a:r>
-            <a:r>
-              <a:rPr sz="1300" dirty="0" err="1">
-                <a:solidFill>
-                  <a:schemeClr val="tx1">
-                    <a:lumMod val="65000"/>
-                    <a:lumOff val="35000"/>
-                  </a:schemeClr>
-                </a:solidFill>
-                <a:latin typeface="Arial Nova Light"/>
-              </a:rPr>
-              <a:t>prototipo</a:t>
-            </a:r>
-            <a:r>
-              <a:rPr sz="1300" dirty="0">
-                <a:solidFill>
-                  <a:schemeClr val="tx1">
-                    <a:lumMod val="65000"/>
-                    <a:lumOff val="35000"/>
-                  </a:schemeClr>
-                </a:solidFill>
-                <a:latin typeface="Arial Nova Light"/>
-              </a:rPr>
-              <a:t> </a:t>
-            </a:r>
-            <a:r>
-              <a:rPr sz="1300" dirty="0" err="1">
-                <a:solidFill>
-                  <a:schemeClr val="tx1">
-                    <a:lumMod val="65000"/>
-                    <a:lumOff val="35000"/>
-                  </a:schemeClr>
-                </a:solidFill>
-                <a:latin typeface="Arial Nova Light"/>
-              </a:rPr>
-              <a:t>desplegado</a:t>
-            </a:r>
-            <a:r>
-              <a:rPr sz="1300" dirty="0">
-                <a:solidFill>
-                  <a:schemeClr val="tx1">
-                    <a:lumMod val="65000"/>
-                    <a:lumOff val="35000"/>
-                  </a:schemeClr>
-                </a:solidFill>
-                <a:latin typeface="Arial Nova Light"/>
-              </a:rPr>
-              <a:t> </a:t>
-            </a:r>
-            <a:r>
-              <a:rPr sz="1300" dirty="0" err="1">
-                <a:solidFill>
-                  <a:schemeClr val="tx1">
-                    <a:lumMod val="65000"/>
-                    <a:lumOff val="35000"/>
-                  </a:schemeClr>
-                </a:solidFill>
-                <a:latin typeface="Arial Nova Light"/>
-              </a:rPr>
-              <a:t>aún</a:t>
-            </a:r>
-            <a:r>
-              <a:rPr sz="1300" dirty="0">
-                <a:solidFill>
-                  <a:schemeClr val="tx1">
-                    <a:lumMod val="65000"/>
-                    <a:lumOff val="35000"/>
-                  </a:schemeClr>
-                </a:solidFill>
-                <a:latin typeface="Arial Nova Light"/>
-              </a:rPr>
-              <a:t>).</a:t>
+              <a:t>calidad por etiquetado humano (κ=0,627, bajo el umbral de 0,80 que exige la rúbrica); LLM juez intentado y descartado (κ=0,515, no validó); costo &lt;$0,01 USD por esta prueba; latencia por medir (sin prototipo desplegado aún).</a:t>
             </a:r>
           </a:p>
         </p:txBody>
@@ -7376,7 +6956,7 @@
         <p:spPr>
           <a:xfrm>
             <a:off x="8298485" y="2644221"/>
-            <a:ext cx="3125114" cy="2468880"/>
+            <a:ext cx="3125114" cy="3447742"/>
           </a:xfrm>
           <a:prstGeom prst="rect">
             <a:avLst/>
@@ -7440,6 +7020,21 @@
               </a:rPr>
               <a:t>3 tiendas al azar.</a:t>
             </a:r>
+            <a:endParaRPr lang="es-MX" sz="1300" dirty="0">
+              <a:solidFill>
+                <a:schemeClr val="tx1">
+                  <a:lumMod val="65000"/>
+                  <a:lumOff val="35000"/>
+                </a:schemeClr>
+              </a:solidFill>
+              <a:latin typeface="Arial Nova Light"/>
+            </a:endParaRPr>
+          </a:p>
+          <a:p>
+            <a:pPr marL="342900" indent="-342900">
+              <a:buFont typeface="+mj-lt"/>
+              <a:buAutoNum type="arabicPeriod"/>
+            </a:pPr>
             <a:endParaRPr lang="en-US" sz="1300" dirty="0">
               <a:solidFill>
                 <a:schemeClr val="tx1">
@@ -7610,12 +7205,36 @@
               </a:rPr>
               <a:t> Gamarra.com.pe / Mi Gamarra), sin NLP.</a:t>
             </a:r>
+            <a:endParaRPr lang="es-MX" sz="1300" dirty="0">
+              <a:solidFill>
+                <a:schemeClr val="tx1">
+                  <a:lumMod val="65000"/>
+                  <a:lumOff val="35000"/>
+                </a:schemeClr>
+              </a:solidFill>
+              <a:latin typeface="Arial Nova Light"/>
+            </a:endParaRPr>
           </a:p>
           <a:p>
             <a:pPr marL="342900" indent="-342900">
               <a:buFont typeface="+mj-lt"/>
               <a:buAutoNum type="arabicPeriod"/>
             </a:pPr>
+            <a:endParaRPr sz="1300" dirty="0">
+              <a:solidFill>
+                <a:schemeClr val="tx1">
+                  <a:lumMod val="65000"/>
+                  <a:lumOff val="35000"/>
+                </a:schemeClr>
+              </a:solidFill>
+              <a:latin typeface="Arial Nova Light"/>
+            </a:endParaRPr>
+          </a:p>
+          <a:p>
+            <a:pPr marL="342900" indent="-342900">
+              <a:buFont typeface="+mj-lt"/>
+              <a:buAutoNum type="arabicPeriod"/>
+            </a:pPr>
             <a:r>
               <a:rPr sz="1300" b="1" dirty="0">
                 <a:solidFill>
@@ -7712,6 +7331,30 @@
               </a:rPr>
               <a:t>.</a:t>
             </a:r>
+            <a:endParaRPr lang="es-MX" sz="1300" dirty="0">
+              <a:solidFill>
+                <a:schemeClr val="tx1">
+                  <a:lumMod val="65000"/>
+                  <a:lumOff val="35000"/>
+                </a:schemeClr>
+              </a:solidFill>
+              <a:latin typeface="Arial Nova Light"/>
+            </a:endParaRPr>
+          </a:p>
+          <a:p>
+            <a:pPr marL="342900" indent="-342900">
+              <a:buFont typeface="+mj-lt"/>
+              <a:buAutoNum type="arabicPeriod"/>
+            </a:pPr>
+            <a:endParaRPr sz="1300" dirty="0">
+              <a:solidFill>
+                <a:schemeClr val="tx1">
+                  <a:lumMod val="65000"/>
+                  <a:lumOff val="35000"/>
+                </a:schemeClr>
+              </a:solidFill>
+              <a:latin typeface="Arial Nova Light"/>
+            </a:endParaRPr>
           </a:p>
           <a:p>
             <a:pPr marL="342900" indent="-342900">
@@ -8965,7 +8608,7 @@
         </p:nvSpPr>
         <p:spPr>
           <a:xfrm>
-            <a:off x="4533290" y="2809055"/>
+            <a:off x="4533290" y="2673289"/>
             <a:ext cx="3125114" cy="2468880"/>
           </a:xfrm>
           <a:prstGeom prst="rect">
@@ -9573,8 +9216,8 @@
         </p:nvSpPr>
         <p:spPr>
           <a:xfrm>
-            <a:off x="8216189" y="2740354"/>
-            <a:ext cx="3125114" cy="2468880"/>
+            <a:off x="8216189" y="2673288"/>
+            <a:ext cx="3125114" cy="3590351"/>
           </a:xfrm>
           <a:prstGeom prst="rect">
             <a:avLst/>
@@ -9850,7 +9493,7 @@
               <a:buChar char="•"/>
             </a:pPr>
             <a:r>
-              <a:rPr sz="1300" dirty="0" err="1">
+              <a:rPr sz="1300" b="1" dirty="0" err="1">
                 <a:solidFill>
                   <a:schemeClr val="bg2">
                     <a:lumMod val="50000"/>
@@ -9858,10 +9501,10 @@
                 </a:solidFill>
                 <a:latin typeface="Arial Nova Light"/>
               </a:rPr>
-              <a:t>Resultado</a:t>
-            </a:r>
-            <a:r>
-              <a:rPr sz="1300" dirty="0">
+              <a:t>Resultado real: </a:t>
+            </a:r>
+            <a:r>
+              <a:rPr sz="1300" dirty="0" err="1">
                 <a:solidFill>
                   <a:schemeClr val="bg2">
                     <a:lumMod val="50000"/>
@@ -9869,73 +9512,7 @@
                 </a:solidFill>
                 <a:latin typeface="Arial Nova Light"/>
               </a:rPr>
-              <a:t> real: SÍ </a:t>
-            </a:r>
-            <a:r>
-              <a:rPr sz="1300" dirty="0" err="1">
-                <a:solidFill>
-                  <a:schemeClr val="bg2">
-                    <a:lumMod val="50000"/>
-                  </a:schemeClr>
-                </a:solidFill>
-                <a:latin typeface="Arial Nova Light"/>
-              </a:rPr>
-              <a:t>superó</a:t>
-            </a:r>
-            <a:r>
-              <a:rPr sz="1300" dirty="0">
-                <a:solidFill>
-                  <a:schemeClr val="bg2">
-                    <a:lumMod val="50000"/>
-                  </a:schemeClr>
-                </a:solidFill>
-                <a:latin typeface="Arial Nova Light"/>
-              </a:rPr>
-              <a:t>, </a:t>
-            </a:r>
-            <a:r>
-              <a:rPr sz="1300" dirty="0" err="1">
-                <a:solidFill>
-                  <a:schemeClr val="bg2">
-                    <a:lumMod val="50000"/>
-                  </a:schemeClr>
-                </a:solidFill>
-                <a:latin typeface="Arial Nova Light"/>
-              </a:rPr>
-              <a:t>intervalos</a:t>
-            </a:r>
-            <a:r>
-              <a:rPr sz="1300" dirty="0">
-                <a:solidFill>
-                  <a:schemeClr val="bg2">
-                    <a:lumMod val="50000"/>
-                  </a:schemeClr>
-                </a:solidFill>
-                <a:latin typeface="Arial Nova Light"/>
-              </a:rPr>
-              <a:t> no se </a:t>
-            </a:r>
-            <a:r>
-              <a:rPr sz="1300" dirty="0" err="1">
-                <a:solidFill>
-                  <a:schemeClr val="bg2">
-                    <a:lumMod val="50000"/>
-                  </a:schemeClr>
-                </a:solidFill>
-                <a:latin typeface="Arial Nova Light"/>
-              </a:rPr>
-              <a:t>cruzan</a:t>
-            </a:r>
-            <a:r>
-              <a:rPr sz="1300" dirty="0">
-                <a:solidFill>
-                  <a:schemeClr val="bg2">
-                    <a:lumMod val="50000"/>
-                  </a:schemeClr>
-                </a:solidFill>
-                <a:latin typeface="Arial Nova Light"/>
-              </a:rPr>
-              <a:t>.</a:t>
+              <a:t>SÍ superó a los baselines (intervalos no se cruzan); NO alcanzó la meta pre-registrada de 70% (66,9% &lt; 70%). Decisión: filtro híbrido (metadata + embeddings) para marca/talla/precio, y revisión del segmento ambiguo, antes del prototipo del 21-nov.</a:t>
             </a:r>
             <a:endParaRPr lang="es-MX" sz="1300" dirty="0">
               <a:solidFill>
@@ -13774,7 +13351,7 @@
                         <a:rPr sz="1200" dirty="0">
                           <a:latin typeface="Arial Nova" panose="020B0504020202020204" pitchFamily="34" charset="0"/>
                         </a:rPr>
-                        <a:t>240 (ponder.)</a:t>
+                        <a:t>240 (150 sin ponderar)</a:t>
                       </a:r>
                     </a:p>
                   </a:txBody>
@@ -13829,7 +13406,7 @@
                         <a:rPr sz="1200" dirty="0">
                           <a:latin typeface="Arial Nova" panose="020B0504020202020204" pitchFamily="34" charset="0"/>
                         </a:rPr>
-                        <a:t>79,6%</a:t>
+                        <a:t>79,6% [IC95 74,6-84,6]</a:t>
                       </a:r>
                     </a:p>
                   </a:txBody>
@@ -14056,7 +13633,7 @@
                         <a:rPr sz="1200">
                           <a:latin typeface="Arial Nova" panose="020B0504020202020204" pitchFamily="34" charset="0"/>
                         </a:rPr>
-                        <a:t>113 (ponder.)</a:t>
+                        <a:t>113 (105 sin ponderar)</a:t>
                       </a:r>
                     </a:p>
                   </a:txBody>
@@ -14111,7 +13688,7 @@
                         <a:rPr sz="1200">
                           <a:latin typeface="Arial Nova" panose="020B0504020202020204" pitchFamily="34" charset="0"/>
                         </a:rPr>
-                        <a:t>50,4%</a:t>
+                        <a:t>50,4% [IC95 41,6-60,2]</a:t>
                       </a:r>
                     </a:p>
                   </a:txBody>
@@ -14467,7 +14044,7 @@
                         <a:rPr sz="1200" dirty="0">
                           <a:latin typeface="Arial Nova" panose="020B0504020202020204" pitchFamily="34" charset="0"/>
                         </a:rPr>
-                        <a:t>25 (ponder.)</a:t>
+                        <a:t>25 (25 sin ponderar)</a:t>
                       </a:r>
                     </a:p>
                   </a:txBody>
@@ -14522,7 +14099,7 @@
                         <a:rPr sz="1200" dirty="0">
                           <a:latin typeface="Arial Nova" panose="020B0504020202020204" pitchFamily="34" charset="0"/>
                         </a:rPr>
-                        <a:t>20,0%</a:t>
+                        <a:t>20,0% [IC95 4,0-36,0]</a:t>
                       </a:r>
                     </a:p>
                   </a:txBody>
@@ -14887,7 +14464,427 @@
               <a:buNone/>
             </a:pPr>
             <a:r>
-              <a:rPr sz="1300" dirty="0" err="1">
+              <a:rPr sz="1200" b="1" dirty="0">
+                <a:solidFill>
+                  <a:schemeClr val="tx1">
+                    <a:lumMod val="75000"/>
+                    <a:lumOff val="25000"/>
+                  </a:schemeClr>
+                </a:solidFill>
+                <a:latin typeface="Arial Nova Light"/>
+              </a:rPr>
+              <a:t>Nota: </a:t>
+            </a:r>
+            <a:r>
+              <a:rPr lang="es-MX" sz="1200" dirty="0">
+                <a:solidFill>
+                  <a:schemeClr val="tx1">
+                    <a:lumMod val="75000"/>
+                    <a:lumOff val="25000"/>
+                  </a:schemeClr>
+                </a:solidFill>
+                <a:latin typeface="Arial Nova Light"/>
+              </a:rPr>
+              <a:t>L</a:t>
+            </a:r>
+            <a:r>
+              <a:rPr sz="1200" dirty="0">
+                <a:solidFill>
+                  <a:schemeClr val="tx1">
+                    <a:lumMod val="75000"/>
+                    <a:lumOff val="25000"/>
+                  </a:schemeClr>
+                </a:solidFill>
+                <a:latin typeface="Arial Nova Light"/>
+              </a:rPr>
+              <a:t>a '</a:t>
+            </a:r>
+            <a:r>
+              <a:rPr sz="1200" dirty="0" err="1">
+                <a:solidFill>
+                  <a:schemeClr val="tx1">
+                    <a:lumMod val="75000"/>
+                    <a:lumOff val="25000"/>
+                  </a:schemeClr>
+                </a:solidFill>
+                <a:latin typeface="Arial Nova Light"/>
+              </a:rPr>
+              <a:t>diferencia</a:t>
+            </a:r>
+            <a:r>
+              <a:rPr sz="1200" dirty="0">
+                <a:solidFill>
+                  <a:schemeClr val="tx1">
+                    <a:lumMod val="75000"/>
+                    <a:lumOff val="25000"/>
+                  </a:schemeClr>
+                </a:solidFill>
+                <a:latin typeface="Arial Nova Light"/>
+              </a:rPr>
+              <a:t> </a:t>
+            </a:r>
+            <a:r>
+              <a:rPr sz="1200" dirty="0" err="1">
+                <a:solidFill>
+                  <a:schemeClr val="tx1">
+                    <a:lumMod val="75000"/>
+                    <a:lumOff val="25000"/>
+                  </a:schemeClr>
+                </a:solidFill>
+                <a:latin typeface="Arial Nova Light"/>
+              </a:rPr>
+              <a:t>frente</a:t>
+            </a:r>
+            <a:r>
+              <a:rPr sz="1200" dirty="0">
+                <a:solidFill>
+                  <a:schemeClr val="tx1">
+                    <a:lumMod val="75000"/>
+                    <a:lumOff val="25000"/>
+                  </a:schemeClr>
+                </a:solidFill>
+                <a:latin typeface="Arial Nova Light"/>
+              </a:rPr>
+              <a:t> al total' es un </a:t>
+            </a:r>
+            <a:r>
+              <a:rPr sz="1200" dirty="0" err="1">
+                <a:solidFill>
+                  <a:schemeClr val="tx1">
+                    <a:lumMod val="75000"/>
+                    <a:lumOff val="25000"/>
+                  </a:schemeClr>
+                </a:solidFill>
+                <a:latin typeface="Arial Nova Light"/>
+              </a:rPr>
+              <a:t>número</a:t>
+            </a:r>
+            <a:r>
+              <a:rPr sz="1200" dirty="0">
+                <a:solidFill>
+                  <a:schemeClr val="tx1">
+                    <a:lumMod val="75000"/>
+                    <a:lumOff val="25000"/>
+                  </a:schemeClr>
+                </a:solidFill>
+                <a:latin typeface="Arial Nova Light"/>
+              </a:rPr>
+              <a:t> </a:t>
+            </a:r>
+            <a:r>
+              <a:rPr sz="1200" dirty="0" err="1">
+                <a:solidFill>
+                  <a:schemeClr val="tx1">
+                    <a:lumMod val="75000"/>
+                    <a:lumOff val="25000"/>
+                  </a:schemeClr>
+                </a:solidFill>
+                <a:latin typeface="Arial Nova Light"/>
+              </a:rPr>
+              <a:t>puntual</a:t>
+            </a:r>
+            <a:r>
+              <a:rPr sz="1200" dirty="0">
+                <a:solidFill>
+                  <a:schemeClr val="tx1">
+                    <a:lumMod val="75000"/>
+                    <a:lumOff val="25000"/>
+                  </a:schemeClr>
+                </a:solidFill>
+                <a:latin typeface="Arial Nova Light"/>
+              </a:rPr>
+              <a:t>, sin </a:t>
+            </a:r>
+            <a:r>
+              <a:rPr sz="1200" dirty="0" err="1">
+                <a:solidFill>
+                  <a:schemeClr val="tx1">
+                    <a:lumMod val="75000"/>
+                    <a:lumOff val="25000"/>
+                  </a:schemeClr>
+                </a:solidFill>
+                <a:latin typeface="Arial Nova Light"/>
+              </a:rPr>
+              <a:t>intervalo</a:t>
+            </a:r>
+            <a:r>
+              <a:rPr sz="1200" dirty="0">
+                <a:solidFill>
+                  <a:schemeClr val="tx1">
+                    <a:lumMod val="75000"/>
+                    <a:lumOff val="25000"/>
+                  </a:schemeClr>
+                </a:solidFill>
+                <a:latin typeface="Arial Nova Light"/>
+              </a:rPr>
+              <a:t> </a:t>
+            </a:r>
+            <a:r>
+              <a:rPr sz="1200" dirty="0" err="1">
+                <a:solidFill>
+                  <a:schemeClr val="tx1">
+                    <a:lumMod val="75000"/>
+                    <a:lumOff val="25000"/>
+                  </a:schemeClr>
+                </a:solidFill>
+                <a:latin typeface="Arial Nova Light"/>
+              </a:rPr>
+              <a:t>propio</a:t>
+            </a:r>
+            <a:r>
+              <a:rPr sz="1200" dirty="0">
+                <a:solidFill>
+                  <a:schemeClr val="tx1">
+                    <a:lumMod val="75000"/>
+                    <a:lumOff val="25000"/>
+                  </a:schemeClr>
+                </a:solidFill>
+                <a:latin typeface="Arial Nova Light"/>
+              </a:rPr>
+              <a:t>; el </a:t>
+            </a:r>
+            <a:r>
+              <a:rPr sz="1200" dirty="0" err="1">
+                <a:solidFill>
+                  <a:schemeClr val="tx1">
+                    <a:lumMod val="75000"/>
+                    <a:lumOff val="25000"/>
+                  </a:schemeClr>
+                </a:solidFill>
+                <a:latin typeface="Arial Nova Light"/>
+              </a:rPr>
+              <a:t>segmento</a:t>
+            </a:r>
+            <a:r>
+              <a:rPr sz="1200" dirty="0">
+                <a:solidFill>
+                  <a:schemeClr val="tx1">
+                    <a:lumMod val="75000"/>
+                    <a:lumOff val="25000"/>
+                  </a:schemeClr>
+                </a:solidFill>
+                <a:latin typeface="Arial Nova Light"/>
+              </a:rPr>
+              <a:t> de </a:t>
+            </a:r>
+            <a:r>
+              <a:rPr sz="1200" dirty="0" err="1">
+                <a:solidFill>
+                  <a:schemeClr val="tx1">
+                    <a:lumMod val="75000"/>
+                    <a:lumOff val="25000"/>
+                  </a:schemeClr>
+                </a:solidFill>
+                <a:latin typeface="Arial Nova Light"/>
+              </a:rPr>
+              <a:t>marca</a:t>
+            </a:r>
+            <a:r>
+              <a:rPr sz="1200" dirty="0">
+                <a:solidFill>
+                  <a:schemeClr val="tx1">
+                    <a:lumMod val="75000"/>
+                    <a:lumOff val="25000"/>
+                  </a:schemeClr>
+                </a:solidFill>
+                <a:latin typeface="Arial Nova Light"/>
+              </a:rPr>
+              <a:t>/</a:t>
+            </a:r>
+            <a:r>
+              <a:rPr sz="1200" dirty="0" err="1">
+                <a:solidFill>
+                  <a:schemeClr val="tx1">
+                    <a:lumMod val="75000"/>
+                    <a:lumOff val="25000"/>
+                  </a:schemeClr>
+                </a:solidFill>
+                <a:latin typeface="Arial Nova Light"/>
+              </a:rPr>
+              <a:t>talla</a:t>
+            </a:r>
+            <a:r>
+              <a:rPr sz="1200" dirty="0">
+                <a:solidFill>
+                  <a:schemeClr val="tx1">
+                    <a:lumMod val="75000"/>
+                    <a:lumOff val="25000"/>
+                  </a:schemeClr>
+                </a:solidFill>
+                <a:latin typeface="Arial Nova Light"/>
+              </a:rPr>
+              <a:t>/</a:t>
+            </a:r>
+            <a:r>
+              <a:rPr sz="1200" dirty="0" err="1">
+                <a:solidFill>
+                  <a:schemeClr val="tx1">
+                    <a:lumMod val="75000"/>
+                    <a:lumOff val="25000"/>
+                  </a:schemeClr>
+                </a:solidFill>
+                <a:latin typeface="Arial Nova Light"/>
+              </a:rPr>
+              <a:t>precio</a:t>
+            </a:r>
+            <a:r>
+              <a:rPr sz="1200" dirty="0">
+                <a:solidFill>
+                  <a:schemeClr val="tx1">
+                    <a:lumMod val="75000"/>
+                    <a:lumOff val="25000"/>
+                  </a:schemeClr>
+                </a:solidFill>
+                <a:latin typeface="Arial Nova Light"/>
+              </a:rPr>
+              <a:t> es el </a:t>
+            </a:r>
+            <a:r>
+              <a:rPr sz="1200" dirty="0" err="1">
+                <a:solidFill>
+                  <a:schemeClr val="tx1">
+                    <a:lumMod val="75000"/>
+                    <a:lumOff val="25000"/>
+                  </a:schemeClr>
+                </a:solidFill>
+                <a:latin typeface="Arial Nova Light"/>
+              </a:rPr>
+              <a:t>más</a:t>
+            </a:r>
+            <a:r>
+              <a:rPr sz="1200" dirty="0">
+                <a:solidFill>
+                  <a:schemeClr val="tx1">
+                    <a:lumMod val="75000"/>
+                    <a:lumOff val="25000"/>
+                  </a:schemeClr>
+                </a:solidFill>
+                <a:latin typeface="Arial Nova Light"/>
+              </a:rPr>
+              <a:t> chico (n=25, IC95% de 4,0% a 36,0%) y se lee </a:t>
+            </a:r>
+            <a:r>
+              <a:rPr sz="1200" dirty="0" err="1">
+                <a:solidFill>
+                  <a:schemeClr val="tx1">
+                    <a:lumMod val="75000"/>
+                    <a:lumOff val="25000"/>
+                  </a:schemeClr>
+                </a:solidFill>
+                <a:latin typeface="Arial Nova Light"/>
+              </a:rPr>
+              <a:t>como</a:t>
+            </a:r>
+            <a:r>
+              <a:rPr sz="1200" dirty="0">
+                <a:solidFill>
+                  <a:schemeClr val="tx1">
+                    <a:lumMod val="75000"/>
+                    <a:lumOff val="25000"/>
+                  </a:schemeClr>
+                </a:solidFill>
+                <a:latin typeface="Arial Nova Light"/>
+              </a:rPr>
+              <a:t> </a:t>
+            </a:r>
+            <a:r>
+              <a:rPr sz="1200" dirty="0" err="1">
+                <a:solidFill>
+                  <a:schemeClr val="tx1">
+                    <a:lumMod val="75000"/>
+                    <a:lumOff val="25000"/>
+                  </a:schemeClr>
+                </a:solidFill>
+                <a:latin typeface="Arial Nova Light"/>
+              </a:rPr>
+              <a:t>indicio</a:t>
+            </a:r>
+            <a:r>
+              <a:rPr sz="1200" dirty="0">
+                <a:solidFill>
+                  <a:schemeClr val="tx1">
+                    <a:lumMod val="75000"/>
+                    <a:lumOff val="25000"/>
+                  </a:schemeClr>
+                </a:solidFill>
+                <a:latin typeface="Arial Nova Light"/>
+              </a:rPr>
+              <a:t>, no </a:t>
+            </a:r>
+            <a:r>
+              <a:rPr sz="1200" dirty="0" err="1">
+                <a:solidFill>
+                  <a:schemeClr val="tx1">
+                    <a:lumMod val="75000"/>
+                    <a:lumOff val="25000"/>
+                  </a:schemeClr>
+                </a:solidFill>
+                <a:latin typeface="Arial Nova Light"/>
+              </a:rPr>
+              <a:t>como</a:t>
+            </a:r>
+            <a:r>
+              <a:rPr sz="1200" dirty="0">
+                <a:solidFill>
+                  <a:schemeClr val="tx1">
+                    <a:lumMod val="75000"/>
+                    <a:lumOff val="25000"/>
+                  </a:schemeClr>
+                </a:solidFill>
+                <a:latin typeface="Arial Nova Light"/>
+              </a:rPr>
+              <a:t> </a:t>
+            </a:r>
+            <a:r>
+              <a:rPr sz="1200" dirty="0" err="1">
+                <a:solidFill>
+                  <a:schemeClr val="tx1">
+                    <a:lumMod val="75000"/>
+                    <a:lumOff val="25000"/>
+                  </a:schemeClr>
+                </a:solidFill>
+                <a:latin typeface="Arial Nova Light"/>
+              </a:rPr>
+              <a:t>conclusión</a:t>
+            </a:r>
+            <a:r>
+              <a:rPr sz="1200" dirty="0">
+                <a:solidFill>
+                  <a:schemeClr val="tx1">
+                    <a:lumMod val="75000"/>
+                    <a:lumOff val="25000"/>
+                  </a:schemeClr>
+                </a:solidFill>
+                <a:latin typeface="Arial Nova Light"/>
+              </a:rPr>
+              <a:t> </a:t>
+            </a:r>
+            <a:r>
+              <a:rPr sz="1200" dirty="0" err="1">
+                <a:solidFill>
+                  <a:schemeClr val="tx1">
+                    <a:lumMod val="75000"/>
+                    <a:lumOff val="25000"/>
+                  </a:schemeClr>
+                </a:solidFill>
+                <a:latin typeface="Arial Nova Light"/>
+              </a:rPr>
+              <a:t>firme</a:t>
+            </a:r>
+            <a:r>
+              <a:rPr sz="1200" dirty="0">
+                <a:solidFill>
+                  <a:schemeClr val="tx1">
+                    <a:lumMod val="75000"/>
+                    <a:lumOff val="25000"/>
+                  </a:schemeClr>
+                </a:solidFill>
+                <a:latin typeface="Arial Nova Light"/>
+              </a:rPr>
+              <a:t>. </a:t>
+            </a:r>
+            <a:r>
+              <a:rPr sz="1200" dirty="0" err="1">
                 <a:solidFill>
                   <a:schemeClr val="tx1">
                     <a:lumMod val="75000"/>
@@ -14899,7 +14896,7 @@
               <a:t>Declaramos</a:t>
             </a:r>
             <a:r>
-              <a:rPr sz="1300" dirty="0">
+              <a:rPr sz="1200" dirty="0">
                 <a:solidFill>
                   <a:schemeClr val="tx1">
                     <a:lumMod val="75000"/>
@@ -14911,7 +14908,7 @@
               <a:t> el </a:t>
             </a:r>
             <a:r>
-              <a:rPr sz="1300" dirty="0" err="1">
+              <a:rPr sz="1200" dirty="0" err="1">
                 <a:solidFill>
                   <a:schemeClr val="tx1">
                     <a:lumMod val="75000"/>
@@ -14923,7 +14920,7 @@
               <a:t>segmento</a:t>
             </a:r>
             <a:r>
-              <a:rPr sz="1300" dirty="0">
+              <a:rPr sz="1200" dirty="0">
                 <a:solidFill>
                   <a:schemeClr val="tx1">
                     <a:lumMod val="75000"/>
@@ -14935,7 +14932,7 @@
               <a:t> de </a:t>
             </a:r>
             <a:r>
-              <a:rPr sz="1300" dirty="0" err="1">
+              <a:rPr sz="1200" dirty="0" err="1">
                 <a:solidFill>
                   <a:schemeClr val="tx1">
                     <a:lumMod val="75000"/>
@@ -14947,7 +14944,7 @@
               <a:t>marca</a:t>
             </a:r>
             <a:r>
-              <a:rPr sz="1300" dirty="0">
+              <a:rPr sz="1200" dirty="0">
                 <a:solidFill>
                   <a:schemeClr val="tx1">
                     <a:lumMod val="75000"/>
@@ -14959,7 +14956,7 @@
               <a:t>/</a:t>
             </a:r>
             <a:r>
-              <a:rPr sz="1300" dirty="0" err="1">
+              <a:rPr sz="1200" dirty="0" err="1">
                 <a:solidFill>
                   <a:schemeClr val="tx1">
                     <a:lumMod val="75000"/>
@@ -14971,7 +14968,7 @@
               <a:t>talla</a:t>
             </a:r>
             <a:r>
-              <a:rPr sz="1300" dirty="0">
+              <a:rPr sz="1200" dirty="0">
                 <a:solidFill>
                   <a:schemeClr val="tx1">
                     <a:lumMod val="75000"/>
@@ -14983,7 +14980,7 @@
               <a:t>/</a:t>
             </a:r>
             <a:r>
-              <a:rPr sz="1300" dirty="0" err="1">
+              <a:rPr sz="1200" dirty="0" err="1">
                 <a:solidFill>
                   <a:schemeClr val="tx1">
                     <a:lumMod val="75000"/>
@@ -14995,7 +14992,7 @@
               <a:t>precio</a:t>
             </a:r>
             <a:r>
-              <a:rPr sz="1300" dirty="0">
+              <a:rPr sz="1200" dirty="0">
                 <a:solidFill>
                   <a:schemeClr val="tx1">
                     <a:lumMod val="75000"/>
@@ -15007,7 +15004,7 @@
               <a:t> </a:t>
             </a:r>
             <a:r>
-              <a:rPr sz="1300" dirty="0" err="1">
+              <a:rPr sz="1200" dirty="0" err="1">
                 <a:solidFill>
                   <a:schemeClr val="tx1">
                     <a:lumMod val="75000"/>
@@ -15019,7 +15016,7 @@
               <a:t>como</a:t>
             </a:r>
             <a:r>
-              <a:rPr sz="1300" dirty="0">
+              <a:rPr sz="1200" dirty="0">
                 <a:solidFill>
                   <a:schemeClr val="tx1">
                     <a:lumMod val="75000"/>
@@ -15031,7 +15028,7 @@
               <a:t> </a:t>
             </a:r>
             <a:r>
-              <a:rPr sz="1300" dirty="0" err="1">
+              <a:rPr sz="1200" dirty="0" err="1">
                 <a:solidFill>
                   <a:schemeClr val="tx1">
                     <a:lumMod val="75000"/>
@@ -15043,7 +15040,7 @@
               <a:t>limitación</a:t>
             </a:r>
             <a:r>
-              <a:rPr sz="1300" dirty="0">
+              <a:rPr sz="1200" dirty="0">
                 <a:solidFill>
                   <a:schemeClr val="tx1">
                     <a:lumMod val="75000"/>
@@ -15055,7 +15052,7 @@
               <a:t> </a:t>
             </a:r>
             <a:r>
-              <a:rPr sz="1300" dirty="0" err="1">
+              <a:rPr sz="1200" dirty="0" err="1">
                 <a:solidFill>
                   <a:schemeClr val="tx1">
                     <a:lumMod val="75000"/>
@@ -15067,7 +15064,7 @@
               <a:t>conocida</a:t>
             </a:r>
             <a:r>
-              <a:rPr sz="1300" dirty="0">
+              <a:rPr sz="1200" dirty="0">
                 <a:solidFill>
                   <a:schemeClr val="tx1">
                     <a:lumMod val="75000"/>
@@ -15079,7 +15076,7 @@
               <a:t> del v0 (motor </a:t>
             </a:r>
             <a:r>
-              <a:rPr sz="1300" dirty="0" err="1">
+              <a:rPr sz="1200" dirty="0" err="1">
                 <a:solidFill>
                   <a:schemeClr val="tx1">
                     <a:lumMod val="75000"/>
@@ -15091,19 +15088,31 @@
               <a:t>semántico</a:t>
             </a:r>
             <a:r>
-              <a:rPr sz="1300" dirty="0">
-                <a:solidFill>
-                  <a:schemeClr val="tx1">
-                    <a:lumMod val="75000"/>
-                    <a:lumOff val="25000"/>
-                  </a:schemeClr>
-                </a:solidFill>
-                <a:latin typeface="Arial Nova Light"/>
-              </a:rPr>
-              <a:t>, no </a:t>
-            </a:r>
-            <a:r>
-              <a:rPr sz="1300" dirty="0" err="1">
+              <a:rPr sz="1200" dirty="0">
+                <a:solidFill>
+                  <a:schemeClr val="tx1">
+                    <a:lumMod val="75000"/>
+                    <a:lumOff val="25000"/>
+                  </a:schemeClr>
+                </a:solidFill>
+                <a:latin typeface="Arial Nova Light"/>
+              </a:rPr>
+              <a:t>, no</a:t>
+            </a:r>
+            <a:r>
+              <a:rPr lang="es-MX" sz="1200" dirty="0">
+                <a:solidFill>
+                  <a:schemeClr val="tx1">
+                    <a:lumMod val="75000"/>
+                    <a:lumOff val="25000"/>
+                  </a:schemeClr>
+                </a:solidFill>
+                <a:latin typeface="Arial Nova Light"/>
+              </a:rPr>
+              <a:t> </a:t>
+            </a:r>
+            <a:r>
+              <a:rPr sz="1200" dirty="0" err="1">
                 <a:solidFill>
                   <a:schemeClr val="tx1">
                     <a:lumMod val="75000"/>
@@ -15115,7 +15124,7 @@
               <a:t>estructurado</a:t>
             </a:r>
             <a:r>
-              <a:rPr sz="1300" dirty="0">
+              <a:rPr sz="1200" dirty="0">
                 <a:solidFill>
                   <a:schemeClr val="tx1">
                     <a:lumMod val="75000"/>
@@ -15127,7 +15136,7 @@
               <a:t>) y </a:t>
             </a:r>
             <a:r>
-              <a:rPr sz="1300" dirty="0" err="1">
+              <a:rPr sz="1200" dirty="0" err="1">
                 <a:solidFill>
                   <a:schemeClr val="tx1">
                     <a:lumMod val="75000"/>
@@ -15139,7 +15148,7 @@
               <a:t>diseñamos</a:t>
             </a:r>
             <a:r>
-              <a:rPr sz="1300" dirty="0">
+              <a:rPr sz="1200" dirty="0">
                 <a:solidFill>
                   <a:schemeClr val="tx1">
                     <a:lumMod val="75000"/>
@@ -15151,7 +15160,7 @@
               <a:t> un </a:t>
             </a:r>
             <a:r>
-              <a:rPr sz="1300" dirty="0" err="1">
+              <a:rPr sz="1200" dirty="0" err="1">
                 <a:solidFill>
                   <a:schemeClr val="tx1">
                     <a:lumMod val="75000"/>
@@ -15163,7 +15172,7 @@
               <a:t>filtro</a:t>
             </a:r>
             <a:r>
-              <a:rPr sz="1300" dirty="0">
+              <a:rPr sz="1200" dirty="0">
                 <a:solidFill>
                   <a:schemeClr val="tx1">
                     <a:lumMod val="75000"/>
@@ -15175,7 +15184,7 @@
               <a:t> </a:t>
             </a:r>
             <a:r>
-              <a:rPr sz="1300" dirty="0" err="1">
+              <a:rPr sz="1200" dirty="0" err="1">
                 <a:solidFill>
                   <a:schemeClr val="tx1">
                     <a:lumMod val="75000"/>
@@ -15187,7 +15196,7 @@
               <a:t>híbrido</a:t>
             </a:r>
             <a:r>
-              <a:rPr sz="1300" dirty="0">
+              <a:rPr sz="1200" dirty="0">
                 <a:solidFill>
                   <a:schemeClr val="tx1">
                     <a:lumMod val="75000"/>
@@ -15199,7 +15208,7 @@
               <a:t> (metadata + embeddings) para el </a:t>
             </a:r>
             <a:r>
-              <a:rPr sz="1300" dirty="0" err="1">
+              <a:rPr sz="1200" dirty="0" err="1">
                 <a:solidFill>
                   <a:schemeClr val="tx1">
                     <a:lumMod val="75000"/>
@@ -15211,7 +15220,7 @@
               <a:t>prototipo</a:t>
             </a:r>
             <a:r>
-              <a:rPr sz="1300" dirty="0">
+              <a:rPr sz="1200" dirty="0">
                 <a:solidFill>
                   <a:schemeClr val="tx1">
                     <a:lumMod val="75000"/>
@@ -15223,7 +15232,7 @@
               <a:t> del 21-nov. El </a:t>
             </a:r>
             <a:r>
-              <a:rPr sz="1300" dirty="0" err="1">
+              <a:rPr sz="1200" dirty="0" err="1">
                 <a:solidFill>
                   <a:schemeClr val="tx1">
                     <a:lumMod val="75000"/>
@@ -15235,7 +15244,7 @@
               <a:t>segmento</a:t>
             </a:r>
             <a:r>
-              <a:rPr sz="1300" dirty="0">
+              <a:rPr sz="1200" dirty="0">
                 <a:solidFill>
                   <a:schemeClr val="tx1">
                     <a:lumMod val="75000"/>
@@ -15247,7 +15256,7 @@
               <a:t> </a:t>
             </a:r>
             <a:r>
-              <a:rPr sz="1300" dirty="0" err="1">
+              <a:rPr sz="1200" dirty="0" err="1">
                 <a:solidFill>
                   <a:schemeClr val="tx1">
                     <a:lumMod val="75000"/>
@@ -15259,7 +15268,7 @@
               <a:t>ambiguo</a:t>
             </a:r>
             <a:r>
-              <a:rPr sz="1300" dirty="0">
+              <a:rPr sz="1200" dirty="0">
                 <a:solidFill>
                   <a:schemeClr val="tx1">
                     <a:lumMod val="75000"/>
@@ -15271,7 +15280,7 @@
               <a:t> </a:t>
             </a:r>
             <a:r>
-              <a:rPr sz="1300" dirty="0" err="1">
+              <a:rPr sz="1200" dirty="0" err="1">
                 <a:solidFill>
                   <a:schemeClr val="tx1">
                     <a:lumMod val="75000"/>
@@ -15283,7 +15292,7 @@
               <a:t>queda</a:t>
             </a:r>
             <a:r>
-              <a:rPr sz="1300" dirty="0">
+              <a:rPr sz="1200" dirty="0">
                 <a:solidFill>
                   <a:schemeClr val="tx1">
                     <a:lumMod val="75000"/>
@@ -15295,7 +15304,7 @@
               <a:t> </a:t>
             </a:r>
             <a:r>
-              <a:rPr sz="1300" dirty="0" err="1">
+              <a:rPr sz="1200" dirty="0" err="1">
                 <a:solidFill>
                   <a:schemeClr val="tx1">
                     <a:lumMod val="75000"/>
@@ -15307,7 +15316,7 @@
               <a:t>documentado</a:t>
             </a:r>
             <a:r>
-              <a:rPr sz="1300" dirty="0">
+              <a:rPr sz="1200" dirty="0">
                 <a:solidFill>
                   <a:schemeClr val="tx1">
                     <a:lumMod val="75000"/>
@@ -15319,7 +15328,7 @@
               <a:t> </a:t>
             </a:r>
             <a:r>
-              <a:rPr sz="1300" dirty="0" err="1">
+              <a:rPr sz="1200" dirty="0" err="1">
                 <a:solidFill>
                   <a:schemeClr val="tx1">
                     <a:lumMod val="75000"/>
@@ -15331,7 +15340,7 @@
               <a:t>en</a:t>
             </a:r>
             <a:r>
-              <a:rPr sz="1300" dirty="0">
+              <a:rPr sz="1200" dirty="0">
                 <a:solidFill>
                   <a:schemeClr val="tx1">
                     <a:lumMod val="75000"/>
@@ -15343,7 +15352,7 @@
               <a:t> el Model Card; no se </a:t>
             </a:r>
             <a:r>
-              <a:rPr sz="1300" dirty="0" err="1">
+              <a:rPr sz="1200" dirty="0" err="1">
                 <a:solidFill>
                   <a:schemeClr val="tx1">
                     <a:lumMod val="75000"/>
@@ -15355,7 +15364,7 @@
               <a:t>fuerza</a:t>
             </a:r>
             <a:r>
-              <a:rPr sz="1300" dirty="0">
+              <a:rPr sz="1200" dirty="0">
                 <a:solidFill>
                   <a:schemeClr val="tx1">
                     <a:lumMod val="75000"/>
@@ -15367,7 +15376,7 @@
               <a:t> </a:t>
             </a:r>
             <a:r>
-              <a:rPr sz="1300" dirty="0" err="1">
+              <a:rPr sz="1200" dirty="0" err="1">
                 <a:solidFill>
                   <a:schemeClr val="tx1">
                     <a:lumMod val="75000"/>
@@ -15379,7 +15388,7 @@
               <a:t>su</a:t>
             </a:r>
             <a:r>
-              <a:rPr sz="1300" dirty="0">
+              <a:rPr sz="1200" dirty="0">
                 <a:solidFill>
                   <a:schemeClr val="tx1">
                     <a:lumMod val="75000"/>
@@ -15391,7 +15400,7 @@
               <a:t> </a:t>
             </a:r>
             <a:r>
-              <a:rPr sz="1300" dirty="0" err="1">
+              <a:rPr sz="1200" dirty="0" err="1">
                 <a:solidFill>
                   <a:schemeClr val="tx1">
                     <a:lumMod val="75000"/>
@@ -15403,7 +15412,7 @@
               <a:t>corrección</a:t>
             </a:r>
             <a:r>
-              <a:rPr sz="1300" dirty="0">
+              <a:rPr sz="1200" dirty="0">
                 <a:solidFill>
                   <a:schemeClr val="tx1">
                     <a:lumMod val="75000"/>
@@ -15415,7 +15424,7 @@
               <a:t> antes de la </a:t>
             </a:r>
             <a:r>
-              <a:rPr sz="1300" dirty="0" err="1">
+              <a:rPr sz="1200" dirty="0" err="1">
                 <a:solidFill>
                   <a:schemeClr val="tx1">
                     <a:lumMod val="75000"/>
@@ -15427,7 +15436,7 @@
               <a:t>entrega</a:t>
             </a:r>
             <a:r>
-              <a:rPr sz="1300" dirty="0">
+              <a:rPr sz="1200" dirty="0">
                 <a:solidFill>
                   <a:schemeClr val="tx1">
                     <a:lumMod val="75000"/>
@@ -15438,7 +15447,7 @@
               </a:rPr>
               <a:t>.</a:t>
             </a:r>
-            <a:endParaRPr lang="en-US" sz="1300" dirty="0">
+            <a:endParaRPr lang="en-US" sz="1200" dirty="0">
               <a:solidFill>
                 <a:schemeClr val="tx1">
                   <a:lumMod val="75000"/>
@@ -18850,7 +18859,7 @@
           <a:bodyPr/>
           <a:lstStyle/>
           <a:p>
-            <a:endParaRPr lang="es-PE"/>
+            <a:endParaRPr lang="es-PE" sz="1600"/>
           </a:p>
         </p:txBody>
       </p:sp>
@@ -18950,7 +18959,7 @@
               <a:buChar char="•"/>
             </a:pPr>
             <a:r>
-              <a:rPr sz="1300" b="1" dirty="0" err="1">
+              <a:rPr sz="1200" b="1" dirty="0" err="1">
                 <a:solidFill>
                   <a:schemeClr val="tx1">
                     <a:lumMod val="75000"/>
@@ -18962,7 +18971,7 @@
               <a:t>Juicios</a:t>
             </a:r>
             <a:r>
-              <a:rPr sz="1300" b="1" dirty="0">
+              <a:rPr sz="1200" b="1" dirty="0">
                 <a:solidFill>
                   <a:schemeClr val="tx1">
                     <a:lumMod val="75000"/>
@@ -18974,7 +18983,7 @@
               <a:t> </a:t>
             </a:r>
             <a:r>
-              <a:rPr sz="1300" b="1" dirty="0" err="1">
+              <a:rPr sz="1200" b="1" dirty="0" err="1">
                 <a:solidFill>
                   <a:schemeClr val="tx1">
                     <a:lumMod val="75000"/>
@@ -18986,7 +18995,7 @@
               <a:t>binarios</a:t>
             </a:r>
             <a:r>
-              <a:rPr sz="1300" b="1" dirty="0">
+              <a:rPr sz="1200" b="1" dirty="0">
                 <a:solidFill>
                   <a:schemeClr val="tx1">
                     <a:lumMod val="75000"/>
@@ -18998,7 +19007,7 @@
               <a:t> </a:t>
             </a:r>
             <a:r>
-              <a:rPr sz="1300" b="1" dirty="0" err="1">
+              <a:rPr sz="1200" b="1" dirty="0" err="1">
                 <a:solidFill>
                   <a:schemeClr val="tx1">
                     <a:lumMod val="75000"/>
@@ -19010,7 +19019,7 @@
               <a:t>Sí</a:t>
             </a:r>
             <a:r>
-              <a:rPr sz="1300" b="1" dirty="0">
+              <a:rPr sz="1200" b="1" dirty="0">
                 <a:solidFill>
                   <a:schemeClr val="tx1">
                     <a:lumMod val="75000"/>
@@ -19022,7 +19031,7 @@
               <a:t>/No </a:t>
             </a:r>
             <a:r>
-              <a:rPr sz="1300" b="1" dirty="0" err="1">
+              <a:rPr sz="1200" b="1" dirty="0" err="1">
                 <a:solidFill>
                   <a:schemeClr val="tx1">
                     <a:lumMod val="75000"/>
@@ -19034,7 +19043,7 @@
               <a:t>etiquetados</a:t>
             </a:r>
             <a:r>
-              <a:rPr sz="1300" b="1" dirty="0">
+              <a:rPr sz="1200" b="1" dirty="0">
                 <a:solidFill>
                   <a:schemeClr val="tx1">
                     <a:lumMod val="75000"/>
@@ -19046,7 +19055,7 @@
               <a:t> </a:t>
             </a:r>
             <a:r>
-              <a:rPr sz="1300" b="1" dirty="0" err="1">
+              <a:rPr sz="1200" b="1" dirty="0" err="1">
                 <a:solidFill>
                   <a:schemeClr val="tx1">
                     <a:lumMod val="75000"/>
@@ -19058,7 +19067,7 @@
               <a:t>por</a:t>
             </a:r>
             <a:r>
-              <a:rPr sz="1300" b="1" dirty="0">
+              <a:rPr sz="1200" b="1" dirty="0">
                 <a:solidFill>
                   <a:schemeClr val="tx1">
                     <a:lumMod val="75000"/>
@@ -19070,7 +19079,7 @@
               <a:t> </a:t>
             </a:r>
             <a:r>
-              <a:rPr sz="1300" b="1" dirty="0" err="1">
+              <a:rPr sz="1200" b="1" dirty="0" err="1">
                 <a:solidFill>
                   <a:schemeClr val="tx1">
                     <a:lumMod val="75000"/>
@@ -19082,7 +19091,7 @@
               <a:t>los</a:t>
             </a:r>
             <a:r>
-              <a:rPr sz="1300" b="1" dirty="0">
+              <a:rPr sz="1200" b="1" dirty="0">
                 <a:solidFill>
                   <a:schemeClr val="tx1">
                     <a:lumMod val="75000"/>
@@ -19094,7 +19103,7 @@
               <a:t> 4 </a:t>
             </a:r>
             <a:r>
-              <a:rPr sz="1300" b="1" dirty="0" err="1">
+              <a:rPr sz="1200" b="1" dirty="0" err="1">
                 <a:solidFill>
                   <a:schemeClr val="tx1">
                     <a:lumMod val="75000"/>
@@ -19106,7 +19115,7 @@
               <a:t>integrantes</a:t>
             </a:r>
             <a:r>
-              <a:rPr sz="1300" b="1" dirty="0">
+              <a:rPr sz="1200" b="1" dirty="0">
                 <a:solidFill>
                   <a:schemeClr val="tx1">
                     <a:lumMod val="75000"/>
@@ -19118,7 +19127,7 @@
               <a:t>, doble </a:t>
             </a:r>
             <a:r>
-              <a:rPr sz="1300" b="1" dirty="0" err="1">
+              <a:rPr sz="1200" b="1" dirty="0" err="1">
                 <a:solidFill>
                   <a:schemeClr val="tx1">
                     <a:lumMod val="75000"/>
@@ -19130,7 +19139,7 @@
               <a:t>ciego</a:t>
             </a:r>
             <a:r>
-              <a:rPr sz="1300" b="1" dirty="0">
+              <a:rPr sz="1200" b="1" dirty="0">
                 <a:solidFill>
                   <a:schemeClr val="tx1">
                     <a:lumMod val="75000"/>
@@ -19142,7 +19151,7 @@
               <a:t> + </a:t>
             </a:r>
             <a:r>
-              <a:rPr sz="1300" b="1" dirty="0" err="1">
+              <a:rPr sz="1200" b="1" dirty="0" err="1">
                 <a:solidFill>
                   <a:schemeClr val="tx1">
                     <a:lumMod val="75000"/>
@@ -19154,7 +19163,7 @@
               <a:t>desempate</a:t>
             </a:r>
             <a:r>
-              <a:rPr sz="1300" b="1" dirty="0">
+              <a:rPr sz="1200" b="1" dirty="0">
                 <a:solidFill>
                   <a:schemeClr val="tx1">
                     <a:lumMod val="75000"/>
@@ -19166,7 +19175,7 @@
               <a:t> con </a:t>
             </a:r>
             <a:r>
-              <a:rPr sz="1300" b="1" dirty="0" err="1">
+              <a:rPr sz="1200" b="1" dirty="0" err="1">
                 <a:solidFill>
                   <a:schemeClr val="tx1">
                     <a:lumMod val="75000"/>
@@ -19178,7 +19187,7 @@
               <a:t>reglas</a:t>
             </a:r>
             <a:r>
-              <a:rPr sz="1300" b="1" dirty="0">
+              <a:rPr sz="1200" b="1" dirty="0">
                 <a:solidFill>
                   <a:schemeClr val="tx1">
                     <a:lumMod val="75000"/>
@@ -19190,7 +19199,7 @@
               <a:t> </a:t>
             </a:r>
             <a:r>
-              <a:rPr sz="1300" b="1" dirty="0" err="1">
+              <a:rPr sz="1200" b="1" dirty="0" err="1">
                 <a:solidFill>
                   <a:schemeClr val="tx1">
                     <a:lumMod val="75000"/>
@@ -19202,7 +19211,7 @@
               <a:t>escritas</a:t>
             </a:r>
             <a:r>
-              <a:rPr sz="1300" dirty="0">
+              <a:rPr sz="1200" dirty="0">
                 <a:solidFill>
                   <a:schemeClr val="tx1">
                     <a:lumMod val="75000"/>
@@ -19213,7 +19222,7 @@
               </a:rPr>
               <a:t>.</a:t>
             </a:r>
-            <a:endParaRPr lang="es-MX" sz="1300" dirty="0">
+            <a:endParaRPr lang="es-MX" sz="1200" dirty="0">
               <a:solidFill>
                 <a:schemeClr val="tx1">
                   <a:lumMod val="75000"/>
@@ -19228,7 +19237,7 @@
               <a:buFont typeface="Arial" panose="020B0604020202020204" pitchFamily="34" charset="0"/>
               <a:buChar char="•"/>
             </a:pPr>
-            <a:endParaRPr lang="es-MX" sz="1300" dirty="0">
+            <a:endParaRPr lang="es-MX" sz="1200" dirty="0">
               <a:solidFill>
                 <a:schemeClr val="tx1">
                   <a:lumMod val="75000"/>
@@ -19244,7 +19253,7 @@
               <a:buChar char="•"/>
             </a:pPr>
             <a:r>
-              <a:rPr sz="1300" b="1" dirty="0">
+              <a:rPr sz="1200" b="1" dirty="0">
                 <a:solidFill>
                   <a:schemeClr val="tx1">
                     <a:lumMod val="75000"/>
@@ -19256,7 +19265,7 @@
               <a:t>LLM </a:t>
             </a:r>
             <a:r>
-              <a:rPr sz="1300" b="1" dirty="0" err="1">
+              <a:rPr sz="1200" b="1" dirty="0" err="1">
                 <a:solidFill>
                   <a:schemeClr val="tx1">
                     <a:lumMod val="75000"/>
@@ -19268,7 +19277,7 @@
               <a:t>juez</a:t>
             </a:r>
             <a:r>
-              <a:rPr sz="1300" b="1" dirty="0">
+              <a:rPr sz="1200" b="1" dirty="0">
                 <a:solidFill>
                   <a:schemeClr val="tx1">
                     <a:lumMod val="75000"/>
@@ -19280,7 +19289,7 @@
               <a:t> (Claude)</a:t>
             </a:r>
             <a:r>
-              <a:rPr sz="1300" dirty="0">
+              <a:rPr sz="1200" dirty="0">
                 <a:solidFill>
                   <a:schemeClr val="tx1">
                     <a:lumMod val="75000"/>
@@ -19292,7 +19301,7 @@
               <a:t> </a:t>
             </a:r>
             <a:r>
-              <a:rPr sz="1300" dirty="0" err="1">
+              <a:rPr sz="1200" dirty="0" err="1">
                 <a:solidFill>
                   <a:schemeClr val="tx1">
                     <a:lumMod val="75000"/>
@@ -19304,7 +19313,7 @@
               <a:t>intentado</a:t>
             </a:r>
             <a:r>
-              <a:rPr sz="1300" dirty="0">
+              <a:rPr sz="1200" dirty="0">
                 <a:solidFill>
                   <a:schemeClr val="tx1">
                     <a:lumMod val="75000"/>
@@ -19316,7 +19325,7 @@
               <a:t> primero: κ=0,515, no </a:t>
             </a:r>
             <a:r>
-              <a:rPr sz="1300" dirty="0" err="1">
+              <a:rPr sz="1200" dirty="0" err="1">
                 <a:solidFill>
                   <a:schemeClr val="tx1">
                     <a:lumMod val="75000"/>
@@ -19328,7 +19337,7 @@
               <a:t>validó</a:t>
             </a:r>
             <a:r>
-              <a:rPr sz="1300" dirty="0">
+              <a:rPr sz="1200" dirty="0">
                 <a:solidFill>
                   <a:schemeClr val="tx1">
                     <a:lumMod val="75000"/>
@@ -19339,7 +19348,7 @@
               </a:rPr>
               <a:t>.</a:t>
             </a:r>
-            <a:endParaRPr lang="es-MX" sz="1300" dirty="0">
+            <a:endParaRPr lang="es-MX" sz="1200" dirty="0">
               <a:solidFill>
                 <a:schemeClr val="tx1">
                   <a:lumMod val="75000"/>
@@ -19354,7 +19363,7 @@
               <a:buFont typeface="Arial" panose="020B0604020202020204" pitchFamily="34" charset="0"/>
               <a:buChar char="•"/>
             </a:pPr>
-            <a:endParaRPr lang="es-MX" sz="1300" dirty="0">
+            <a:endParaRPr lang="es-MX" sz="1200" dirty="0">
               <a:solidFill>
                 <a:schemeClr val="tx1">
                   <a:lumMod val="75000"/>
@@ -19370,7 +19379,7 @@
               <a:buChar char="•"/>
             </a:pPr>
             <a:r>
-              <a:rPr sz="1300" b="1" dirty="0">
+              <a:rPr sz="1200" b="1" dirty="0">
                 <a:solidFill>
                   <a:schemeClr val="tx1">
                     <a:lumMod val="75000"/>
@@ -19382,7 +19391,7 @@
               <a:t>Humano-</a:t>
             </a:r>
             <a:r>
-              <a:rPr sz="1300" b="1" dirty="0" err="1">
+              <a:rPr sz="1200" b="1" dirty="0" err="1">
                 <a:solidFill>
                   <a:schemeClr val="tx1">
                     <a:lumMod val="75000"/>
@@ -19394,7 +19403,7 @@
               <a:t>humano</a:t>
             </a:r>
             <a:r>
-              <a:rPr sz="1300" b="1" dirty="0">
+              <a:rPr sz="1200" b="1" dirty="0">
                 <a:solidFill>
                   <a:schemeClr val="tx1">
                     <a:lumMod val="75000"/>
@@ -19406,282 +19415,18 @@
               <a:t>: </a:t>
             </a:r>
             <a:r>
-              <a:rPr sz="1300" dirty="0">
-                <a:solidFill>
-                  <a:schemeClr val="tx1">
-                    <a:lumMod val="75000"/>
-                    <a:lumOff val="25000"/>
-                  </a:schemeClr>
-                </a:solidFill>
-                <a:latin typeface="Arial Nova Light"/>
-              </a:rPr>
-              <a:t>κ≈0,6 </a:t>
-            </a:r>
-            <a:r>
-              <a:rPr sz="1300" dirty="0" err="1">
-                <a:solidFill>
-                  <a:schemeClr val="tx1">
-                    <a:lumMod val="75000"/>
-                    <a:lumOff val="25000"/>
-                  </a:schemeClr>
-                </a:solidFill>
-                <a:latin typeface="Arial Nova Light"/>
-              </a:rPr>
-              <a:t>en</a:t>
-            </a:r>
-            <a:r>
-              <a:rPr sz="1300" dirty="0">
-                <a:solidFill>
-                  <a:schemeClr val="tx1">
-                    <a:lumMod val="75000"/>
-                    <a:lumOff val="25000"/>
-                  </a:schemeClr>
-                </a:solidFill>
-                <a:latin typeface="Arial Nova Light"/>
-              </a:rPr>
-              <a:t> </a:t>
-            </a:r>
-            <a:r>
-              <a:rPr sz="1300" dirty="0" err="1">
-                <a:solidFill>
-                  <a:schemeClr val="tx1">
-                    <a:lumMod val="75000"/>
-                    <a:lumOff val="25000"/>
-                  </a:schemeClr>
-                </a:solidFill>
-                <a:latin typeface="Arial Nova Light"/>
-              </a:rPr>
-              <a:t>consultas</a:t>
-            </a:r>
-            <a:r>
-              <a:rPr sz="1300" dirty="0">
-                <a:solidFill>
-                  <a:schemeClr val="tx1">
-                    <a:lumMod val="75000"/>
-                    <a:lumOff val="25000"/>
-                  </a:schemeClr>
-                </a:solidFill>
-                <a:latin typeface="Arial Nova Light"/>
-              </a:rPr>
-              <a:t> </a:t>
-            </a:r>
-            <a:r>
-              <a:rPr sz="1300" dirty="0" err="1">
-                <a:solidFill>
-                  <a:schemeClr val="tx1">
-                    <a:lumMod val="75000"/>
-                    <a:lumOff val="25000"/>
-                  </a:schemeClr>
-                </a:solidFill>
-                <a:latin typeface="Arial Nova Light"/>
-              </a:rPr>
-              <a:t>generales</a:t>
-            </a:r>
-            <a:r>
-              <a:rPr sz="1300" dirty="0">
-                <a:solidFill>
-                  <a:schemeClr val="tx1">
-                    <a:lumMod val="75000"/>
-                    <a:lumOff val="25000"/>
-                  </a:schemeClr>
-                </a:solidFill>
-                <a:latin typeface="Arial Nova Light"/>
-              </a:rPr>
-              <a:t> (3 </a:t>
-            </a:r>
-            <a:r>
-              <a:rPr sz="1300" dirty="0" err="1">
-                <a:solidFill>
-                  <a:schemeClr val="tx1">
-                    <a:lumMod val="75000"/>
-                    <a:lumOff val="25000"/>
-                  </a:schemeClr>
-                </a:solidFill>
-                <a:latin typeface="Arial Nova Light"/>
-              </a:rPr>
-              <a:t>réplicas</a:t>
-            </a:r>
-            <a:r>
-              <a:rPr sz="1300" dirty="0">
-                <a:solidFill>
-                  <a:schemeClr val="tx1">
-                    <a:lumMod val="75000"/>
-                    <a:lumOff val="25000"/>
-                  </a:schemeClr>
-                </a:solidFill>
-                <a:latin typeface="Arial Nova Light"/>
-              </a:rPr>
-              <a:t> </a:t>
-            </a:r>
-            <a:r>
-              <a:rPr sz="1300" dirty="0" err="1">
-                <a:solidFill>
-                  <a:schemeClr val="tx1">
-                    <a:lumMod val="75000"/>
-                    <a:lumOff val="25000"/>
-                  </a:schemeClr>
-                </a:solidFill>
-                <a:latin typeface="Arial Nova Light"/>
-              </a:rPr>
-              <a:t>independientes</a:t>
-            </a:r>
-            <a:r>
-              <a:rPr sz="1300" dirty="0">
-                <a:solidFill>
-                  <a:schemeClr val="tx1">
-                    <a:lumMod val="75000"/>
-                    <a:lumOff val="25000"/>
-                  </a:schemeClr>
-                </a:solidFill>
-                <a:latin typeface="Arial Nova Light"/>
-              </a:rPr>
-              <a:t>); κ=0,86-0,88 </a:t>
-            </a:r>
-            <a:r>
-              <a:rPr sz="1300" dirty="0" err="1">
-                <a:solidFill>
-                  <a:schemeClr val="tx1">
-                    <a:lumMod val="75000"/>
-                    <a:lumOff val="25000"/>
-                  </a:schemeClr>
-                </a:solidFill>
-                <a:latin typeface="Arial Nova Light"/>
-              </a:rPr>
-              <a:t>en</a:t>
-            </a:r>
-            <a:r>
-              <a:rPr sz="1300" dirty="0">
-                <a:solidFill>
-                  <a:schemeClr val="tx1">
-                    <a:lumMod val="75000"/>
-                    <a:lumOff val="25000"/>
-                  </a:schemeClr>
-                </a:solidFill>
-                <a:latin typeface="Arial Nova Light"/>
-              </a:rPr>
-              <a:t> </a:t>
-            </a:r>
-            <a:r>
-              <a:rPr sz="1300" dirty="0" err="1">
-                <a:solidFill>
-                  <a:schemeClr val="tx1">
-                    <a:lumMod val="75000"/>
-                    <a:lumOff val="25000"/>
-                  </a:schemeClr>
-                </a:solidFill>
-                <a:latin typeface="Arial Nova Light"/>
-              </a:rPr>
-              <a:t>los</a:t>
-            </a:r>
-            <a:r>
-              <a:rPr sz="1300" dirty="0">
-                <a:solidFill>
-                  <a:schemeClr val="tx1">
-                    <a:lumMod val="75000"/>
-                    <a:lumOff val="25000"/>
-                  </a:schemeClr>
-                </a:solidFill>
-                <a:latin typeface="Arial Nova Light"/>
-              </a:rPr>
-              <a:t> pares </a:t>
-            </a:r>
-            <a:r>
-              <a:rPr sz="1300" dirty="0" err="1">
-                <a:solidFill>
-                  <a:schemeClr val="tx1">
-                    <a:lumMod val="75000"/>
-                    <a:lumOff val="25000"/>
-                  </a:schemeClr>
-                </a:solidFill>
-                <a:latin typeface="Arial Nova Light"/>
-              </a:rPr>
-              <a:t>nuevos</a:t>
-            </a:r>
-            <a:r>
-              <a:rPr sz="1300" dirty="0">
-                <a:solidFill>
-                  <a:schemeClr val="tx1">
-                    <a:lumMod val="75000"/>
-                    <a:lumOff val="25000"/>
-                  </a:schemeClr>
-                </a:solidFill>
-                <a:latin typeface="Arial Nova Light"/>
-              </a:rPr>
-              <a:t> </a:t>
-            </a:r>
-            <a:r>
-              <a:rPr sz="1300" dirty="0" err="1">
-                <a:solidFill>
-                  <a:schemeClr val="tx1">
-                    <a:lumMod val="75000"/>
-                    <a:lumOff val="25000"/>
-                  </a:schemeClr>
-                </a:solidFill>
-                <a:latin typeface="Arial Nova Light"/>
-              </a:rPr>
-              <a:t>propuestos</a:t>
-            </a:r>
-            <a:r>
-              <a:rPr sz="1300" dirty="0">
-                <a:solidFill>
-                  <a:schemeClr val="tx1">
-                    <a:lumMod val="75000"/>
-                    <a:lumOff val="25000"/>
-                  </a:schemeClr>
-                </a:solidFill>
-                <a:latin typeface="Arial Nova Light"/>
-              </a:rPr>
-              <a:t> </a:t>
-            </a:r>
-            <a:r>
-              <a:rPr sz="1300" dirty="0" err="1">
-                <a:solidFill>
-                  <a:schemeClr val="tx1">
-                    <a:lumMod val="75000"/>
-                    <a:lumOff val="25000"/>
-                  </a:schemeClr>
-                </a:solidFill>
-                <a:latin typeface="Arial Nova Light"/>
-              </a:rPr>
-              <a:t>por</a:t>
-            </a:r>
-            <a:r>
-              <a:rPr sz="1300" dirty="0">
-                <a:solidFill>
-                  <a:schemeClr val="tx1">
-                    <a:lumMod val="75000"/>
-                    <a:lumOff val="25000"/>
-                  </a:schemeClr>
-                </a:solidFill>
-                <a:latin typeface="Arial Nova Light"/>
-              </a:rPr>
-              <a:t> </a:t>
-            </a:r>
-            <a:r>
-              <a:rPr sz="1300" dirty="0" err="1">
-                <a:solidFill>
-                  <a:schemeClr val="tx1">
-                    <a:lumMod val="75000"/>
-                    <a:lumOff val="25000"/>
-                  </a:schemeClr>
-                </a:solidFill>
-                <a:latin typeface="Arial Nova Light"/>
-              </a:rPr>
-              <a:t>modelo</a:t>
-            </a:r>
-            <a:r>
-              <a:rPr sz="1300" dirty="0">
-                <a:solidFill>
-                  <a:schemeClr val="tx1">
-                    <a:lumMod val="75000"/>
-                    <a:lumOff val="25000"/>
-                  </a:schemeClr>
-                </a:solidFill>
-                <a:latin typeface="Arial Nova Light"/>
-              </a:rPr>
-              <a:t> v0.</a:t>
-            </a:r>
-            <a:endParaRPr lang="en-US" sz="1300" dirty="0">
+              <a:rPr sz="1200" dirty="0">
+                <a:solidFill>
+                  <a:schemeClr val="tx1">
+                    <a:lumMod val="75000"/>
+                    <a:lumOff val="25000"/>
+                  </a:schemeClr>
+                </a:solidFill>
+                <a:latin typeface="Arial Nova Light"/>
+              </a:rPr>
+              <a:t>acuerdo bruto 87,4% / κ=0,627 en consultas generales (reevaluación ciega real, 3 réplicas independientes); acuerdo 93-94% / κ=0,86-0,88 en los pares nuevos propuestos por modelo v0.</a:t>
+            </a:r>
+            <a:endParaRPr lang="en-US" sz="1200" dirty="0">
               <a:solidFill>
                 <a:schemeClr val="tx1">
                   <a:lumMod val="75000"/>
@@ -19803,7 +19548,7 @@
         <p:spPr>
           <a:xfrm>
             <a:off x="910948" y="4681727"/>
-            <a:ext cx="4966564" cy="1622183"/>
+            <a:ext cx="4966564" cy="1664572"/>
           </a:xfrm>
           <a:prstGeom prst="rect">
             <a:avLst/>
@@ -19820,7 +19565,7 @@
               <a:buChar char="•"/>
             </a:pPr>
             <a:r>
-              <a:rPr sz="1300" b="1" dirty="0">
+              <a:rPr sz="1200" b="1" dirty="0">
                 <a:solidFill>
                   <a:schemeClr val="tx1">
                     <a:lumMod val="75000"/>
@@ -19832,7 +19577,7 @@
               <a:t>No filtra </a:t>
             </a:r>
             <a:r>
-              <a:rPr sz="1300" b="1" dirty="0" err="1">
+              <a:rPr sz="1200" b="1" dirty="0" err="1">
                 <a:solidFill>
                   <a:schemeClr val="tx1">
                     <a:lumMod val="75000"/>
@@ -19844,7 +19589,7 @@
               <a:t>talla</a:t>
             </a:r>
             <a:r>
-              <a:rPr sz="1300" b="1" dirty="0">
+              <a:rPr sz="1200" b="1" dirty="0">
                 <a:solidFill>
                   <a:schemeClr val="tx1">
                     <a:lumMod val="75000"/>
@@ -19856,7 +19601,7 @@
               <a:t>/</a:t>
             </a:r>
             <a:r>
-              <a:rPr sz="1300" b="1" dirty="0" err="1">
+              <a:rPr sz="1200" b="1" dirty="0" err="1">
                 <a:solidFill>
                   <a:schemeClr val="tx1">
                     <a:lumMod val="75000"/>
@@ -19868,7 +19613,7 @@
               <a:t>precio</a:t>
             </a:r>
             <a:r>
-              <a:rPr sz="1300" b="1" dirty="0">
+              <a:rPr sz="1200" b="1" dirty="0">
                 <a:solidFill>
                   <a:schemeClr val="tx1">
                     <a:lumMod val="75000"/>
@@ -19880,7 +19625,7 @@
               <a:t>/</a:t>
             </a:r>
             <a:r>
-              <a:rPr sz="1300" b="1" dirty="0" err="1">
+              <a:rPr sz="1200" b="1" dirty="0" err="1">
                 <a:solidFill>
                   <a:schemeClr val="tx1">
                     <a:lumMod val="75000"/>
@@ -19892,7 +19637,7 @@
               <a:t>disponibilidad</a:t>
             </a:r>
             <a:r>
-              <a:rPr sz="1300" b="1" dirty="0">
+              <a:rPr sz="1200" b="1" dirty="0">
                 <a:solidFill>
                   <a:schemeClr val="tx1">
                     <a:lumMod val="75000"/>
@@ -19904,426 +19649,18 @@
               <a:t> real </a:t>
             </a:r>
             <a:r>
-              <a:rPr sz="1300" dirty="0">
-                <a:solidFill>
-                  <a:schemeClr val="tx1">
-                    <a:lumMod val="75000"/>
-                    <a:lumOff val="25000"/>
-                  </a:schemeClr>
-                </a:solidFill>
-                <a:latin typeface="Arial Nova Light"/>
-              </a:rPr>
-              <a:t>(HR@3 </a:t>
-            </a:r>
-            <a:r>
-              <a:rPr sz="1300" dirty="0" err="1">
-                <a:solidFill>
-                  <a:schemeClr val="tx1">
-                    <a:lumMod val="75000"/>
-                    <a:lumOff val="25000"/>
-                  </a:schemeClr>
-                </a:solidFill>
-                <a:latin typeface="Arial Nova Light"/>
-              </a:rPr>
-              <a:t>cae</a:t>
-            </a:r>
-            <a:r>
-              <a:rPr sz="1300" dirty="0">
-                <a:solidFill>
-                  <a:schemeClr val="tx1">
-                    <a:lumMod val="75000"/>
-                    <a:lumOff val="25000"/>
-                  </a:schemeClr>
-                </a:solidFill>
-                <a:latin typeface="Arial Nova Light"/>
-              </a:rPr>
-              <a:t> a 20% ahí). El </a:t>
-            </a:r>
-            <a:r>
-              <a:rPr sz="1300" dirty="0" err="1">
-                <a:solidFill>
-                  <a:schemeClr val="tx1">
-                    <a:lumMod val="75000"/>
-                    <a:lumOff val="25000"/>
-                  </a:schemeClr>
-                </a:solidFill>
-                <a:latin typeface="Arial Nova Light"/>
-              </a:rPr>
-              <a:t>acuerdo</a:t>
-            </a:r>
-            <a:r>
-              <a:rPr sz="1300" dirty="0">
-                <a:solidFill>
-                  <a:schemeClr val="tx1">
-                    <a:lumMod val="75000"/>
-                    <a:lumOff val="25000"/>
-                  </a:schemeClr>
-                </a:solidFill>
-                <a:latin typeface="Arial Nova Light"/>
-              </a:rPr>
-              <a:t> </a:t>
-            </a:r>
-            <a:r>
-              <a:rPr sz="1300" dirty="0" err="1">
-                <a:solidFill>
-                  <a:schemeClr val="tx1">
-                    <a:lumMod val="75000"/>
-                    <a:lumOff val="25000"/>
-                  </a:schemeClr>
-                </a:solidFill>
-                <a:latin typeface="Arial Nova Light"/>
-              </a:rPr>
-              <a:t>humano</a:t>
-            </a:r>
-            <a:r>
-              <a:rPr sz="1300" dirty="0">
-                <a:solidFill>
-                  <a:schemeClr val="tx1">
-                    <a:lumMod val="75000"/>
-                    <a:lumOff val="25000"/>
-                  </a:schemeClr>
-                </a:solidFill>
-                <a:latin typeface="Arial Nova Light"/>
-              </a:rPr>
-              <a:t> </a:t>
-            </a:r>
-            <a:r>
-              <a:rPr sz="1300" dirty="0" err="1">
-                <a:solidFill>
-                  <a:schemeClr val="tx1">
-                    <a:lumMod val="75000"/>
-                    <a:lumOff val="25000"/>
-                  </a:schemeClr>
-                </a:solidFill>
-                <a:latin typeface="Arial Nova Light"/>
-              </a:rPr>
-              <a:t>sobre</a:t>
-            </a:r>
-            <a:r>
-              <a:rPr sz="1300" dirty="0">
-                <a:solidFill>
-                  <a:schemeClr val="tx1">
-                    <a:lumMod val="75000"/>
-                    <a:lumOff val="25000"/>
-                  </a:schemeClr>
-                </a:solidFill>
-                <a:latin typeface="Arial Nova Light"/>
-              </a:rPr>
-              <a:t> '</a:t>
-            </a:r>
-            <a:r>
-              <a:rPr sz="1300" dirty="0" err="1">
-                <a:solidFill>
-                  <a:schemeClr val="tx1">
-                    <a:lumMod val="75000"/>
-                    <a:lumOff val="25000"/>
-                  </a:schemeClr>
-                </a:solidFill>
-                <a:latin typeface="Arial Nova Light"/>
-              </a:rPr>
-              <a:t>relevante</a:t>
-            </a:r>
-            <a:r>
-              <a:rPr sz="1300" dirty="0">
-                <a:solidFill>
-                  <a:schemeClr val="tx1">
-                    <a:lumMod val="75000"/>
-                    <a:lumOff val="25000"/>
-                  </a:schemeClr>
-                </a:solidFill>
-                <a:latin typeface="Arial Nova Light"/>
-              </a:rPr>
-              <a:t>' </a:t>
-            </a:r>
-            <a:r>
-              <a:rPr sz="1300" dirty="0" err="1">
-                <a:solidFill>
-                  <a:schemeClr val="tx1">
-                    <a:lumMod val="75000"/>
-                    <a:lumOff val="25000"/>
-                  </a:schemeClr>
-                </a:solidFill>
-                <a:latin typeface="Arial Nova Light"/>
-              </a:rPr>
-              <a:t>tiene</a:t>
-            </a:r>
-            <a:r>
-              <a:rPr sz="1300" dirty="0">
-                <a:solidFill>
-                  <a:schemeClr val="tx1">
-                    <a:lumMod val="75000"/>
-                    <a:lumOff val="25000"/>
-                  </a:schemeClr>
-                </a:solidFill>
-                <a:latin typeface="Arial Nova Light"/>
-              </a:rPr>
-              <a:t> un </a:t>
-            </a:r>
-            <a:r>
-              <a:rPr sz="1300" dirty="0" err="1">
-                <a:solidFill>
-                  <a:schemeClr val="tx1">
-                    <a:lumMod val="75000"/>
-                    <a:lumOff val="25000"/>
-                  </a:schemeClr>
-                </a:solidFill>
-                <a:latin typeface="Arial Nova Light"/>
-              </a:rPr>
-              <a:t>techo</a:t>
-            </a:r>
-            <a:r>
-              <a:rPr sz="1300" dirty="0">
-                <a:solidFill>
-                  <a:schemeClr val="tx1">
-                    <a:lumMod val="75000"/>
-                    <a:lumOff val="25000"/>
-                  </a:schemeClr>
-                </a:solidFill>
-                <a:latin typeface="Arial Nova Light"/>
-              </a:rPr>
-              <a:t> real de κ≈0,6 </a:t>
-            </a:r>
-            <a:r>
-              <a:rPr sz="1300" dirty="0" err="1">
-                <a:solidFill>
-                  <a:schemeClr val="tx1">
-                    <a:lumMod val="75000"/>
-                    <a:lumOff val="25000"/>
-                  </a:schemeClr>
-                </a:solidFill>
-                <a:latin typeface="Arial Nova Light"/>
-              </a:rPr>
-              <a:t>en</a:t>
-            </a:r>
-            <a:r>
-              <a:rPr sz="1300" dirty="0">
-                <a:solidFill>
-                  <a:schemeClr val="tx1">
-                    <a:lumMod val="75000"/>
-                    <a:lumOff val="25000"/>
-                  </a:schemeClr>
-                </a:solidFill>
-                <a:latin typeface="Arial Nova Light"/>
-              </a:rPr>
-              <a:t> </a:t>
-            </a:r>
-            <a:r>
-              <a:rPr sz="1300" dirty="0" err="1">
-                <a:solidFill>
-                  <a:schemeClr val="tx1">
-                    <a:lumMod val="75000"/>
-                    <a:lumOff val="25000"/>
-                  </a:schemeClr>
-                </a:solidFill>
-                <a:latin typeface="Arial Nova Light"/>
-              </a:rPr>
-              <a:t>consultas</a:t>
-            </a:r>
-            <a:r>
-              <a:rPr sz="1300" dirty="0">
-                <a:solidFill>
-                  <a:schemeClr val="tx1">
-                    <a:lumMod val="75000"/>
-                    <a:lumOff val="25000"/>
-                  </a:schemeClr>
-                </a:solidFill>
-                <a:latin typeface="Arial Nova Light"/>
-              </a:rPr>
-              <a:t> </a:t>
-            </a:r>
-            <a:r>
-              <a:rPr sz="1300" dirty="0" err="1">
-                <a:solidFill>
-                  <a:schemeClr val="tx1">
-                    <a:lumMod val="75000"/>
-                    <a:lumOff val="25000"/>
-                  </a:schemeClr>
-                </a:solidFill>
-                <a:latin typeface="Arial Nova Light"/>
-              </a:rPr>
-              <a:t>ambiguas</a:t>
-            </a:r>
-            <a:r>
-              <a:rPr sz="1300" dirty="0">
-                <a:solidFill>
-                  <a:schemeClr val="tx1">
-                    <a:lumMod val="75000"/>
-                    <a:lumOff val="25000"/>
-                  </a:schemeClr>
-                </a:solidFill>
-                <a:latin typeface="Arial Nova Light"/>
-              </a:rPr>
-              <a:t> de </a:t>
-            </a:r>
-            <a:r>
-              <a:rPr sz="1300" dirty="0" err="1">
-                <a:solidFill>
-                  <a:schemeClr val="tx1">
-                    <a:lumMod val="75000"/>
-                    <a:lumOff val="25000"/>
-                  </a:schemeClr>
-                </a:solidFill>
-                <a:latin typeface="Arial Nova Light"/>
-              </a:rPr>
-              <a:t>estilo</a:t>
-            </a:r>
-            <a:r>
-              <a:rPr sz="1300" dirty="0">
-                <a:solidFill>
-                  <a:schemeClr val="tx1">
-                    <a:lumMod val="75000"/>
-                    <a:lumOff val="25000"/>
-                  </a:schemeClr>
-                </a:solidFill>
-                <a:latin typeface="Arial Nova Light"/>
-              </a:rPr>
-              <a:t> (yk2, </a:t>
-            </a:r>
-            <a:r>
-              <a:rPr sz="1300" dirty="0" err="1">
-                <a:solidFill>
-                  <a:schemeClr val="tx1">
-                    <a:lumMod val="75000"/>
-                    <a:lumOff val="25000"/>
-                  </a:schemeClr>
-                </a:solidFill>
-                <a:latin typeface="Arial Nova Light"/>
-              </a:rPr>
-              <a:t>años</a:t>
-            </a:r>
-            <a:r>
-              <a:rPr sz="1300" dirty="0">
-                <a:solidFill>
-                  <a:schemeClr val="tx1">
-                    <a:lumMod val="75000"/>
-                    <a:lumOff val="25000"/>
-                  </a:schemeClr>
-                </a:solidFill>
-                <a:latin typeface="Arial Nova Light"/>
-              </a:rPr>
-              <a:t> 2000, 'de </a:t>
-            </a:r>
-            <a:r>
-              <a:rPr sz="1300" dirty="0" err="1">
-                <a:solidFill>
-                  <a:schemeClr val="tx1">
-                    <a:lumMod val="75000"/>
-                    <a:lumOff val="25000"/>
-                  </a:schemeClr>
-                </a:solidFill>
-                <a:latin typeface="Arial Nova Light"/>
-              </a:rPr>
-              <a:t>pinterest</a:t>
-            </a:r>
-            <a:r>
-              <a:rPr sz="1300" dirty="0">
-                <a:solidFill>
-                  <a:schemeClr val="tx1">
-                    <a:lumMod val="75000"/>
-                    <a:lumOff val="25000"/>
-                  </a:schemeClr>
-                </a:solidFill>
-                <a:latin typeface="Arial Nova Light"/>
-              </a:rPr>
-              <a:t>') — el </a:t>
-            </a:r>
-            <a:r>
-              <a:rPr sz="1300" dirty="0" err="1">
-                <a:solidFill>
-                  <a:schemeClr val="tx1">
-                    <a:lumMod val="75000"/>
-                    <a:lumOff val="25000"/>
-                  </a:schemeClr>
-                </a:solidFill>
-                <a:latin typeface="Arial Nova Light"/>
-              </a:rPr>
-              <a:t>catálogo</a:t>
-            </a:r>
-            <a:r>
-              <a:rPr sz="1300" dirty="0">
-                <a:solidFill>
-                  <a:schemeClr val="tx1">
-                    <a:lumMod val="75000"/>
-                    <a:lumOff val="25000"/>
-                  </a:schemeClr>
-                </a:solidFill>
-                <a:latin typeface="Arial Nova Light"/>
-              </a:rPr>
-              <a:t> no </a:t>
-            </a:r>
-            <a:r>
-              <a:rPr sz="1300" dirty="0" err="1">
-                <a:solidFill>
-                  <a:schemeClr val="tx1">
-                    <a:lumMod val="75000"/>
-                    <a:lumOff val="25000"/>
-                  </a:schemeClr>
-                </a:solidFill>
-                <a:latin typeface="Arial Nova Light"/>
-              </a:rPr>
-              <a:t>tiene</a:t>
-            </a:r>
-            <a:r>
-              <a:rPr sz="1300" dirty="0">
-                <a:solidFill>
-                  <a:schemeClr val="tx1">
-                    <a:lumMod val="75000"/>
-                    <a:lumOff val="25000"/>
-                  </a:schemeClr>
-                </a:solidFill>
-                <a:latin typeface="Arial Nova Light"/>
-              </a:rPr>
-              <a:t> </a:t>
-            </a:r>
-            <a:r>
-              <a:rPr sz="1300" dirty="0" err="1">
-                <a:solidFill>
-                  <a:schemeClr val="tx1">
-                    <a:lumMod val="75000"/>
-                    <a:lumOff val="25000"/>
-                  </a:schemeClr>
-                </a:solidFill>
-                <a:latin typeface="Arial Nova Light"/>
-              </a:rPr>
-              <a:t>esas</a:t>
-            </a:r>
-            <a:r>
-              <a:rPr sz="1300" dirty="0">
-                <a:solidFill>
-                  <a:schemeClr val="tx1">
-                    <a:lumMod val="75000"/>
-                    <a:lumOff val="25000"/>
-                  </a:schemeClr>
-                </a:solidFill>
-                <a:latin typeface="Arial Nova Light"/>
-              </a:rPr>
-              <a:t> </a:t>
-            </a:r>
-            <a:r>
-              <a:rPr sz="1300" dirty="0" err="1">
-                <a:solidFill>
-                  <a:schemeClr val="tx1">
-                    <a:lumMod val="75000"/>
-                    <a:lumOff val="25000"/>
-                  </a:schemeClr>
-                </a:solidFill>
-                <a:latin typeface="Arial Nova Light"/>
-              </a:rPr>
-              <a:t>etiquetas</a:t>
-            </a:r>
-            <a:r>
-              <a:rPr sz="1300" dirty="0">
-                <a:solidFill>
-                  <a:schemeClr val="tx1">
-                    <a:lumMod val="75000"/>
-                    <a:lumOff val="25000"/>
-                  </a:schemeClr>
-                </a:solidFill>
-                <a:latin typeface="Arial Nova Light"/>
-              </a:rPr>
-              <a:t>.</a:t>
-            </a:r>
-            <a:endParaRPr lang="es-MX" sz="1300" dirty="0">
+              <a:rPr sz="1200" dirty="0">
+                <a:solidFill>
+                  <a:schemeClr val="tx1">
+                    <a:lumMod val="75000"/>
+                    <a:lumOff val="25000"/>
+                  </a:schemeClr>
+                </a:solidFill>
+                <a:latin typeface="Arial Nova Light"/>
+              </a:rPr>
+              <a:t>(HR@3 cae a 20% ahí; filtro híbrido metadata+embeddings planificado para el prototipo del 21-nov). El acuerdo humano sobre 'relevante' tiene un techo real (87,4% bruto / κ≈0,63) en consultas ambiguas de estilo (yk2, años 2000, 'de pinterest') — el catálogo no tiene esas etiquetas.</a:t>
+            </a:r>
+            <a:endParaRPr lang="es-MX" sz="1200" dirty="0">
               <a:solidFill>
                 <a:schemeClr val="tx1">
                   <a:lumMod val="75000"/>
@@ -20338,7 +19675,7 @@
               <a:buFont typeface="Arial" panose="020B0604020202020204" pitchFamily="34" charset="0"/>
               <a:buChar char="•"/>
             </a:pPr>
-            <a:endParaRPr lang="es-MX" sz="1300" dirty="0">
+            <a:endParaRPr lang="es-MX" sz="1200" dirty="0">
               <a:solidFill>
                 <a:schemeClr val="tx1">
                   <a:lumMod val="75000"/>
@@ -20354,7 +19691,7 @@
               <a:buChar char="•"/>
             </a:pPr>
             <a:r>
-              <a:rPr sz="1300" dirty="0">
+              <a:rPr sz="1200" dirty="0">
                 <a:solidFill>
                   <a:schemeClr val="tx1">
                     <a:lumMod val="75000"/>
@@ -20366,7 +19703,7 @@
               <a:t> </a:t>
             </a:r>
             <a:r>
-              <a:rPr sz="1300" b="1" dirty="0" err="1">
+              <a:rPr sz="1200" b="1" dirty="0" err="1">
                 <a:solidFill>
                   <a:schemeClr val="tx1">
                     <a:lumMod val="75000"/>
@@ -20378,7 +19715,7 @@
               <a:t>Evaluado</a:t>
             </a:r>
             <a:r>
-              <a:rPr sz="1300" b="1" dirty="0">
+              <a:rPr sz="1200" b="1" dirty="0">
                 <a:solidFill>
                   <a:schemeClr val="tx1">
                     <a:lumMod val="75000"/>
@@ -20390,7 +19727,7 @@
               <a:t> </a:t>
             </a:r>
             <a:r>
-              <a:rPr sz="1300" b="1" dirty="0" err="1">
+              <a:rPr sz="1200" b="1" dirty="0" err="1">
                 <a:solidFill>
                   <a:schemeClr val="tx1">
                     <a:lumMod val="75000"/>
@@ -20402,7 +19739,7 @@
               <a:t>sobre</a:t>
             </a:r>
             <a:r>
-              <a:rPr sz="1300" b="1" dirty="0">
+              <a:rPr sz="1200" b="1" dirty="0">
                 <a:solidFill>
                   <a:schemeClr val="tx1">
                     <a:lumMod val="75000"/>
@@ -20414,7 +19751,7 @@
               <a:t> 438/1.853 tiendas y 378/21.186 </a:t>
             </a:r>
             <a:r>
-              <a:rPr sz="1300" b="1" dirty="0" err="1">
+              <a:rPr sz="1200" b="1" dirty="0" err="1">
                 <a:solidFill>
                   <a:schemeClr val="tx1">
                     <a:lumMod val="75000"/>
@@ -20426,7 +19763,7 @@
               <a:t>consultas</a:t>
             </a:r>
             <a:r>
-              <a:rPr sz="1300" b="1" dirty="0">
+              <a:rPr sz="1200" b="1" dirty="0">
                 <a:solidFill>
                   <a:schemeClr val="tx1">
                     <a:lumMod val="75000"/>
@@ -20438,7 +19775,7 @@
               <a:t> </a:t>
             </a:r>
             <a:r>
-              <a:rPr sz="1300" dirty="0">
+              <a:rPr sz="1200" dirty="0">
                 <a:solidFill>
                   <a:schemeClr val="tx1">
                     <a:lumMod val="75000"/>
@@ -20450,7 +19787,7 @@
               <a:t>(</a:t>
             </a:r>
             <a:r>
-              <a:rPr sz="1300" dirty="0" err="1">
+              <a:rPr sz="1200" dirty="0" err="1">
                 <a:solidFill>
                   <a:schemeClr val="tx1">
                     <a:lumMod val="75000"/>
@@ -20462,7 +19799,7 @@
               <a:t>piloto</a:t>
             </a:r>
             <a:r>
-              <a:rPr sz="1300" dirty="0">
+              <a:rPr sz="1200" dirty="0">
                 <a:solidFill>
                   <a:schemeClr val="tx1">
                     <a:lumMod val="75000"/>
@@ -20474,7 +19811,7 @@
               <a:t>, no </a:t>
             </a:r>
             <a:r>
-              <a:rPr sz="1300" dirty="0" err="1">
+              <a:rPr sz="1200" dirty="0" err="1">
                 <a:solidFill>
                   <a:schemeClr val="tx1">
                     <a:lumMod val="75000"/>
@@ -20486,7 +19823,7 @@
               <a:t>universo</a:t>
             </a:r>
             <a:r>
-              <a:rPr sz="1300" dirty="0">
+              <a:rPr sz="1200" dirty="0">
                 <a:solidFill>
                   <a:schemeClr val="tx1">
                     <a:lumMod val="75000"/>
@@ -20498,7 +19835,7 @@
               <a:t> </a:t>
             </a:r>
             <a:r>
-              <a:rPr sz="1300" dirty="0" err="1">
+              <a:rPr sz="1200" dirty="0" err="1">
                 <a:solidFill>
                   <a:schemeClr val="tx1">
                     <a:lumMod val="75000"/>
@@ -20510,7 +19847,7 @@
               <a:t>completo</a:t>
             </a:r>
             <a:r>
-              <a:rPr sz="1300" dirty="0">
+              <a:rPr sz="1200" dirty="0">
                 <a:solidFill>
                   <a:schemeClr val="tx1">
                     <a:lumMod val="75000"/>
@@ -20522,7 +19859,7 @@
               <a:t>). Costo y </a:t>
             </a:r>
             <a:r>
-              <a:rPr sz="1300" dirty="0" err="1">
+              <a:rPr sz="1200" dirty="0" err="1">
                 <a:solidFill>
                   <a:schemeClr val="tx1">
                     <a:lumMod val="75000"/>
@@ -20534,7 +19871,7 @@
               <a:t>latencia</a:t>
             </a:r>
             <a:r>
-              <a:rPr sz="1300" dirty="0">
+              <a:rPr sz="1200" dirty="0">
                 <a:solidFill>
                   <a:schemeClr val="tx1">
                     <a:lumMod val="75000"/>
@@ -20546,7 +19883,7 @@
               <a:t> del </a:t>
             </a:r>
             <a:r>
-              <a:rPr sz="1300" dirty="0" err="1">
+              <a:rPr sz="1200" dirty="0" err="1">
                 <a:solidFill>
                   <a:schemeClr val="tx1">
                     <a:lumMod val="75000"/>
@@ -20558,7 +19895,7 @@
               <a:t>prototipo</a:t>
             </a:r>
             <a:r>
-              <a:rPr sz="1300" dirty="0">
+              <a:rPr sz="1200" dirty="0">
                 <a:solidFill>
                   <a:schemeClr val="tx1">
                     <a:lumMod val="75000"/>
@@ -20570,7 +19907,7 @@
               <a:t> real </a:t>
             </a:r>
             <a:r>
-              <a:rPr sz="1300" dirty="0" err="1">
+              <a:rPr sz="1200" dirty="0" err="1">
                 <a:solidFill>
                   <a:schemeClr val="tx1">
                     <a:lumMod val="75000"/>
@@ -20582,7 +19919,7 @@
               <a:t>aún</a:t>
             </a:r>
             <a:r>
-              <a:rPr sz="1300" dirty="0">
+              <a:rPr sz="1200" dirty="0">
                 <a:solidFill>
                   <a:schemeClr val="tx1">
                     <a:lumMod val="75000"/>
@@ -20594,7 +19931,7 @@
               <a:t> no </a:t>
             </a:r>
             <a:r>
-              <a:rPr sz="1300" dirty="0" err="1">
+              <a:rPr sz="1200" dirty="0" err="1">
                 <a:solidFill>
                   <a:schemeClr val="tx1">
                     <a:lumMod val="75000"/>
@@ -20606,7 +19943,7 @@
               <a:t>medidos</a:t>
             </a:r>
             <a:r>
-              <a:rPr sz="1300" dirty="0">
+              <a:rPr sz="1200" dirty="0">
                 <a:solidFill>
                   <a:schemeClr val="tx1">
                     <a:lumMod val="75000"/>
@@ -20618,7 +19955,7 @@
               <a:t> (sin </a:t>
             </a:r>
             <a:r>
-              <a:rPr sz="1300" dirty="0" err="1">
+              <a:rPr sz="1200" dirty="0" err="1">
                 <a:solidFill>
                   <a:schemeClr val="tx1">
                     <a:lumMod val="75000"/>
@@ -20630,7 +19967,7 @@
               <a:t>despliegue</a:t>
             </a:r>
             <a:r>
-              <a:rPr sz="1300" dirty="0">
+              <a:rPr sz="1200" dirty="0">
                 <a:solidFill>
                   <a:schemeClr val="tx1">
                     <a:lumMod val="75000"/>
@@ -20641,7 +19978,7 @@
               </a:rPr>
               <a:t>).</a:t>
             </a:r>
-            <a:endParaRPr lang="en-US" sz="1300" dirty="0">
+            <a:endParaRPr lang="en-US" sz="1200" dirty="0">
               <a:solidFill>
                 <a:schemeClr val="tx1">
                   <a:lumMod val="75000"/>
@@ -21816,7 +21153,7 @@
         </p:nvSpPr>
         <p:spPr>
           <a:xfrm>
-            <a:off x="685800" y="1097280"/>
+            <a:off x="685798" y="946131"/>
             <a:ext cx="10820095" cy="685800"/>
           </a:xfrm>
           <a:prstGeom prst="rect">
@@ -21855,8 +21192,8 @@
         </p:nvSpPr>
         <p:spPr>
           <a:xfrm>
-            <a:off x="685800" y="1783080"/>
-            <a:ext cx="10820095" cy="457200"/>
+            <a:off x="685799" y="1449050"/>
+            <a:ext cx="10820095" cy="772941"/>
           </a:xfrm>
           <a:prstGeom prst="rect">
             <a:avLst/>
@@ -21880,7 +21217,7 @@
                 <a:ea typeface="Arial Nova Light" pitchFamily="34" charset="-122"/>
                 <a:cs typeface="Arial Nova Light" pitchFamily="34" charset="-120"/>
               </a:rPr>
-              <a:t>El registro del pre-mortem, completo. Categorías: datos · modelo · adopción · ética o regulación</a:t>
+              <a:t>El registro del pre-mortem, completo. Categorías: datos · modelo · adopción · ética o regulación (Se consideró también dependencia de la API de OpenAI y privacidad de las consultas; se priorizaron estos 3 por mayor probabilidad/impacto actual.)</a:t>
             </a:r>
             <a:endParaRPr lang="en-US" sz="1600" dirty="0"/>
           </a:p>
@@ -21966,14 +21303,14 @@
           <p:nvPr>
             <p:extLst>
               <p:ext uri="{D42A27DB-BD31-4B8C-83A1-F6EECF244321}">
-                <p14:modId xmlns:p14="http://schemas.microsoft.com/office/powerpoint/2010/main" val="2665274128"/>
+                <p14:modId xmlns:p14="http://schemas.microsoft.com/office/powerpoint/2010/main" val="3187042776"/>
               </p:ext>
             </p:extLst>
           </p:nvPr>
         </p:nvGraphicFramePr>
         <p:xfrm>
           <a:off x="685800" y="2221992"/>
-          <a:ext cx="10820095" cy="3950208"/>
+          <a:ext cx="10820095" cy="3858768"/>
         </p:xfrm>
         <a:graphic>
           <a:graphicData uri="http://schemas.openxmlformats.org/drawingml/2006/table">
@@ -22595,7 +21932,7 @@
                     <a:lstStyle/>
                     <a:p>
                       <a:r>
-                        <a:rPr sz="1200" dirty="0">
+                        <a:rPr sz="1100" dirty="0">
                           <a:latin typeface="Arial Nova" panose="020B0504020202020204" pitchFamily="34" charset="0"/>
                         </a:rPr>
                         <a:t>1</a:t>
@@ -22650,140 +21987,11 @@
                     <a:lstStyle/>
                     <a:p>
                       <a:r>
-                        <a:rPr sz="1200" dirty="0">
+                        <a:rPr sz="1100" dirty="0">
                           <a:latin typeface="Arial Nova" panose="020B0504020202020204" pitchFamily="34" charset="0"/>
                         </a:rPr>
-                        <a:t>El </a:t>
-                      </a:r>
-                      <a:r>
-                        <a:rPr sz="1200" dirty="0" err="1">
-                          <a:latin typeface="Arial Nova" panose="020B0504020202020204" pitchFamily="34" charset="0"/>
-                        </a:rPr>
-                        <a:t>acuerdo</a:t>
-                      </a:r>
-                      <a:r>
-                        <a:rPr sz="1200" dirty="0">
-                          <a:latin typeface="Arial Nova" panose="020B0504020202020204" pitchFamily="34" charset="0"/>
-                        </a:rPr>
-                        <a:t> </a:t>
-                      </a:r>
-                      <a:r>
-                        <a:rPr sz="1200" dirty="0" err="1">
-                          <a:latin typeface="Arial Nova" panose="020B0504020202020204" pitchFamily="34" charset="0"/>
-                        </a:rPr>
-                        <a:t>humano</a:t>
-                      </a:r>
-                      <a:r>
-                        <a:rPr sz="1200" dirty="0">
-                          <a:latin typeface="Arial Nova" panose="020B0504020202020204" pitchFamily="34" charset="0"/>
-                        </a:rPr>
-                        <a:t> </a:t>
-                      </a:r>
-                      <a:r>
-                        <a:rPr sz="1200" dirty="0" err="1">
-                          <a:latin typeface="Arial Nova" panose="020B0504020202020204" pitchFamily="34" charset="0"/>
-                        </a:rPr>
-                        <a:t>sobre</a:t>
-                      </a:r>
-                      <a:r>
-                        <a:rPr sz="1200" dirty="0">
-                          <a:latin typeface="Arial Nova" panose="020B0504020202020204" pitchFamily="34" charset="0"/>
-                        </a:rPr>
-                        <a:t> </a:t>
-                      </a:r>
-                      <a:r>
-                        <a:rPr sz="1200" dirty="0" err="1">
-                          <a:latin typeface="Arial Nova" panose="020B0504020202020204" pitchFamily="34" charset="0"/>
-                        </a:rPr>
-                        <a:t>relevancia</a:t>
-                      </a:r>
-                      <a:r>
-                        <a:rPr sz="1200" dirty="0">
-                          <a:latin typeface="Arial Nova" panose="020B0504020202020204" pitchFamily="34" charset="0"/>
-                        </a:rPr>
-                        <a:t> </a:t>
-                      </a:r>
-                      <a:r>
-                        <a:rPr sz="1200" dirty="0" err="1">
-                          <a:latin typeface="Arial Nova" panose="020B0504020202020204" pitchFamily="34" charset="0"/>
-                        </a:rPr>
-                        <a:t>tiene</a:t>
-                      </a:r>
-                      <a:r>
-                        <a:rPr sz="1200" dirty="0">
-                          <a:latin typeface="Arial Nova" panose="020B0504020202020204" pitchFamily="34" charset="0"/>
-                        </a:rPr>
-                        <a:t> un </a:t>
-                      </a:r>
-                      <a:r>
-                        <a:rPr sz="1200" dirty="0" err="1">
-                          <a:latin typeface="Arial Nova" panose="020B0504020202020204" pitchFamily="34" charset="0"/>
-                        </a:rPr>
-                        <a:t>techo</a:t>
-                      </a:r>
-                      <a:r>
-                        <a:rPr sz="1200" dirty="0">
-                          <a:latin typeface="Arial Nova" panose="020B0504020202020204" pitchFamily="34" charset="0"/>
-                        </a:rPr>
-                        <a:t> real de κ≈0,6 </a:t>
-                      </a:r>
-                      <a:r>
-                        <a:rPr sz="1200" dirty="0" err="1">
-                          <a:latin typeface="Arial Nova" panose="020B0504020202020204" pitchFamily="34" charset="0"/>
-                        </a:rPr>
-                        <a:t>en</a:t>
-                      </a:r>
-                      <a:r>
-                        <a:rPr sz="1200" dirty="0">
-                          <a:latin typeface="Arial Nova" panose="020B0504020202020204" pitchFamily="34" charset="0"/>
-                        </a:rPr>
-                        <a:t> </a:t>
-                      </a:r>
-                      <a:r>
-                        <a:rPr sz="1200" dirty="0" err="1">
-                          <a:latin typeface="Arial Nova" panose="020B0504020202020204" pitchFamily="34" charset="0"/>
-                        </a:rPr>
-                        <a:t>consultas</a:t>
-                      </a:r>
-                      <a:r>
-                        <a:rPr sz="1200" dirty="0">
-                          <a:latin typeface="Arial Nova" panose="020B0504020202020204" pitchFamily="34" charset="0"/>
-                        </a:rPr>
-                        <a:t> </a:t>
-                      </a:r>
-                      <a:r>
-                        <a:rPr sz="1200" dirty="0" err="1">
-                          <a:latin typeface="Arial Nova" panose="020B0504020202020204" pitchFamily="34" charset="0"/>
-                        </a:rPr>
-                        <a:t>ambiguas</a:t>
-                      </a:r>
-                      <a:r>
-                        <a:rPr sz="1200" dirty="0">
-                          <a:latin typeface="Arial Nova" panose="020B0504020202020204" pitchFamily="34" charset="0"/>
-                        </a:rPr>
-                        <a:t> de </a:t>
-                      </a:r>
-                      <a:r>
-                        <a:rPr sz="1200" dirty="0" err="1">
-                          <a:latin typeface="Arial Nova" panose="020B0504020202020204" pitchFamily="34" charset="0"/>
-                        </a:rPr>
-                        <a:t>estilo</a:t>
-                      </a:r>
-                      <a:r>
-                        <a:rPr sz="1200" dirty="0">
-                          <a:latin typeface="Arial Nova" panose="020B0504020202020204" pitchFamily="34" charset="0"/>
-                        </a:rPr>
-                        <a:t>/</a:t>
-                      </a:r>
-                      <a:r>
-                        <a:rPr sz="1200" dirty="0" err="1">
-                          <a:latin typeface="Arial Nova" panose="020B0504020202020204" pitchFamily="34" charset="0"/>
-                        </a:rPr>
-                        <a:t>tendencia</a:t>
-                      </a:r>
-                      <a:endParaRPr sz="1200" dirty="0">
-                        <a:latin typeface="Arial Nova" panose="020B0504020202020204" pitchFamily="34" charset="0"/>
-                      </a:endParaRPr>
+                        <a:t>Limitación del etiquetado: el acuerdo humano sobre relevancia tiene un techo real (87,4% bruto / κ≈0,63) en consultas ambiguas de estilo/tendencia.</a:t>
+                      </a:r>
                     </a:p>
                   </a:txBody>
                   <a:tcPr marL="64008" marR="64008" marT="64008" marB="64008" anchor="ctr">
@@ -22834,7 +22042,7 @@
                     <a:lstStyle/>
                     <a:p>
                       <a:r>
-                        <a:rPr sz="1200" dirty="0">
+                        <a:rPr sz="1100" dirty="0">
                           <a:latin typeface="Arial Nova" panose="020B0504020202020204" pitchFamily="34" charset="0"/>
                         </a:rPr>
                         <a:t>Datos</a:t>
@@ -22889,7 +22097,7 @@
                     <a:lstStyle/>
                     <a:p>
                       <a:r>
-                        <a:rPr sz="1200" dirty="0">
+                        <a:rPr sz="1100" dirty="0">
                           <a:latin typeface="Arial Nova" panose="020B0504020202020204" pitchFamily="34" charset="0"/>
                         </a:rPr>
                         <a:t>Alta</a:t>
@@ -22944,7 +22152,7 @@
                     <a:lstStyle/>
                     <a:p>
                       <a:r>
-                        <a:rPr sz="1200">
+                        <a:rPr sz="1100">
                           <a:latin typeface="Arial Nova" panose="020B0504020202020204" pitchFamily="34" charset="0"/>
                         </a:rPr>
                         <a:t>Medio</a:t>
@@ -22999,144 +22207,144 @@
                     <a:lstStyle/>
                     <a:p>
                       <a:r>
-                        <a:rPr sz="1200" dirty="0" err="1">
+                        <a:rPr sz="1100" dirty="0" err="1">
                           <a:latin typeface="Arial Nova" panose="020B0504020202020204" pitchFamily="34" charset="0"/>
                         </a:rPr>
                         <a:t>Declarar</a:t>
                       </a:r>
                       <a:r>
-                        <a:rPr sz="1200" dirty="0">
+                        <a:rPr sz="1100" dirty="0">
                           <a:latin typeface="Arial Nova" panose="020B0504020202020204" pitchFamily="34" charset="0"/>
                         </a:rPr>
                         <a:t> la </a:t>
                       </a:r>
                       <a:r>
-                        <a:rPr sz="1200" dirty="0" err="1">
+                        <a:rPr sz="1100" dirty="0" err="1">
                           <a:latin typeface="Arial Nova" panose="020B0504020202020204" pitchFamily="34" charset="0"/>
                         </a:rPr>
                         <a:t>limitación</a:t>
                       </a:r>
                       <a:r>
-                        <a:rPr sz="1200" dirty="0">
+                        <a:rPr sz="1100" dirty="0">
                           <a:latin typeface="Arial Nova" panose="020B0504020202020204" pitchFamily="34" charset="0"/>
                         </a:rPr>
                         <a:t> </a:t>
                       </a:r>
                       <a:r>
-                        <a:rPr sz="1200" dirty="0" err="1">
+                        <a:rPr sz="1100" dirty="0" err="1">
                           <a:latin typeface="Arial Nova" panose="020B0504020202020204" pitchFamily="34" charset="0"/>
                         </a:rPr>
                         <a:t>en</a:t>
                       </a:r>
                       <a:r>
-                        <a:rPr sz="1200" dirty="0">
+                        <a:rPr sz="1100" dirty="0">
                           <a:latin typeface="Arial Nova" panose="020B0504020202020204" pitchFamily="34" charset="0"/>
                         </a:rPr>
                         <a:t> el Model Card; para Capstone II, </a:t>
                       </a:r>
                       <a:r>
-                        <a:rPr sz="1200" dirty="0" err="1">
+                        <a:rPr sz="1100" dirty="0" err="1">
                           <a:latin typeface="Arial Nova" panose="020B0504020202020204" pitchFamily="34" charset="0"/>
                         </a:rPr>
                         <a:t>enriquecer</a:t>
                       </a:r>
                       <a:r>
-                        <a:rPr sz="1200" dirty="0">
+                        <a:rPr sz="1100" dirty="0">
                           <a:latin typeface="Arial Nova" panose="020B0504020202020204" pitchFamily="34" charset="0"/>
                         </a:rPr>
                         <a:t> el </a:t>
                       </a:r>
                       <a:r>
-                        <a:rPr sz="1200" dirty="0" err="1">
+                        <a:rPr sz="1100" dirty="0" err="1">
                           <a:latin typeface="Arial Nova" panose="020B0504020202020204" pitchFamily="34" charset="0"/>
                         </a:rPr>
                         <a:t>catálogo</a:t>
                       </a:r>
                       <a:r>
-                        <a:rPr sz="1200" dirty="0">
+                        <a:rPr sz="1100" dirty="0">
                           <a:latin typeface="Arial Nova" panose="020B0504020202020204" pitchFamily="34" charset="0"/>
                         </a:rPr>
                         <a:t> con </a:t>
                       </a:r>
                       <a:r>
-                        <a:rPr sz="1200" dirty="0" err="1">
+                        <a:rPr sz="1100" dirty="0" err="1">
                           <a:latin typeface="Arial Nova" panose="020B0504020202020204" pitchFamily="34" charset="0"/>
                         </a:rPr>
                         <a:t>etiquetas</a:t>
                       </a:r>
                       <a:r>
-                        <a:rPr sz="1200" dirty="0">
+                        <a:rPr sz="1100" dirty="0">
                           <a:latin typeface="Arial Nova" panose="020B0504020202020204" pitchFamily="34" charset="0"/>
                         </a:rPr>
                         <a:t> de </a:t>
                       </a:r>
                       <a:r>
-                        <a:rPr sz="1200" dirty="0" err="1">
+                        <a:rPr sz="1100" dirty="0" err="1">
                           <a:latin typeface="Arial Nova" panose="020B0504020202020204" pitchFamily="34" charset="0"/>
                         </a:rPr>
                         <a:t>estilo</a:t>
                       </a:r>
                       <a:r>
-                        <a:rPr sz="1200" dirty="0">
+                        <a:rPr sz="1100" dirty="0">
                           <a:latin typeface="Arial Nova" panose="020B0504020202020204" pitchFamily="34" charset="0"/>
                         </a:rPr>
                         <a:t> y </a:t>
                       </a:r>
                       <a:r>
-                        <a:rPr sz="1200" dirty="0" err="1">
+                        <a:rPr sz="1100" dirty="0" err="1">
                           <a:latin typeface="Arial Nova" panose="020B0504020202020204" pitchFamily="34" charset="0"/>
                         </a:rPr>
                         <a:t>repetir</a:t>
                       </a:r>
                       <a:r>
-                        <a:rPr sz="1200" dirty="0">
+                        <a:rPr sz="1100" dirty="0">
                           <a:latin typeface="Arial Nova" panose="020B0504020202020204" pitchFamily="34" charset="0"/>
                         </a:rPr>
                         <a:t> el </a:t>
                       </a:r>
                       <a:r>
-                        <a:rPr sz="1200" dirty="0" err="1">
+                        <a:rPr sz="1100" dirty="0" err="1">
                           <a:latin typeface="Arial Nova" panose="020B0504020202020204" pitchFamily="34" charset="0"/>
                         </a:rPr>
                         <a:t>etiquetado</a:t>
                       </a:r>
                       <a:r>
-                        <a:rPr sz="1200" dirty="0">
+                        <a:rPr sz="1100" dirty="0">
                           <a:latin typeface="Arial Nova" panose="020B0504020202020204" pitchFamily="34" charset="0"/>
                         </a:rPr>
                         <a:t> con </a:t>
                       </a:r>
                       <a:r>
-                        <a:rPr sz="1200" dirty="0" err="1">
+                        <a:rPr sz="1100" dirty="0" err="1">
                           <a:latin typeface="Arial Nova" panose="020B0504020202020204" pitchFamily="34" charset="0"/>
                         </a:rPr>
                         <a:t>guía</a:t>
                       </a:r>
                       <a:r>
-                        <a:rPr sz="1200" dirty="0">
+                        <a:rPr sz="1100" dirty="0">
                           <a:latin typeface="Arial Nova" panose="020B0504020202020204" pitchFamily="34" charset="0"/>
                         </a:rPr>
                         <a:t> </a:t>
                       </a:r>
                       <a:r>
-                        <a:rPr sz="1200" dirty="0" err="1">
+                        <a:rPr sz="1100" dirty="0" err="1">
                           <a:latin typeface="Arial Nova" panose="020B0504020202020204" pitchFamily="34" charset="0"/>
                         </a:rPr>
                         <a:t>más</a:t>
                       </a:r>
                       <a:r>
-                        <a:rPr sz="1200" dirty="0">
+                        <a:rPr sz="1100" dirty="0">
                           <a:latin typeface="Arial Nova" panose="020B0504020202020204" pitchFamily="34" charset="0"/>
                         </a:rPr>
                         <a:t> </a:t>
                       </a:r>
                       <a:r>
-                        <a:rPr sz="1200" dirty="0" err="1">
+                        <a:rPr sz="1100" dirty="0" err="1">
                           <a:latin typeface="Arial Nova" panose="020B0504020202020204" pitchFamily="34" charset="0"/>
                         </a:rPr>
                         <a:t>detallada</a:t>
                       </a:r>
-                      <a:endParaRPr sz="1200" dirty="0">
+                      <a:endParaRPr sz="1100" dirty="0">
                         <a:latin typeface="Arial Nova" panose="020B0504020202020204" pitchFamily="34" charset="0"/>
                       </a:endParaRPr>
                     </a:p>
@@ -23189,11 +22397,104 @@
                     <a:lstStyle/>
                     <a:p>
                       <a:r>
-                        <a:rPr sz="1200">
+                        <a:rPr sz="1100" dirty="0">
                           <a:latin typeface="Arial Nova" panose="020B0504020202020204" pitchFamily="34" charset="0"/>
                         </a:rPr>
-                        <a:t>Kappa de una nueva ronda de etiquetado por debajo de 0,70 al 21 de noviembre</a:t>
-                      </a:r>
+                        <a:t>Kappa de </a:t>
+                      </a:r>
+                      <a:r>
+                        <a:rPr sz="1100" dirty="0" err="1">
+                          <a:latin typeface="Arial Nova" panose="020B0504020202020204" pitchFamily="34" charset="0"/>
+                        </a:rPr>
+                        <a:t>una</a:t>
+                      </a:r>
+                      <a:r>
+                        <a:rPr sz="1100" dirty="0">
+                          <a:latin typeface="Arial Nova" panose="020B0504020202020204" pitchFamily="34" charset="0"/>
+                        </a:rPr>
+                        <a:t> </a:t>
+                      </a:r>
+                      <a:r>
+                        <a:rPr sz="1100" dirty="0" err="1">
+                          <a:latin typeface="Arial Nova" panose="020B0504020202020204" pitchFamily="34" charset="0"/>
+                        </a:rPr>
+                        <a:t>nueva</a:t>
+                      </a:r>
+                      <a:r>
+                        <a:rPr sz="1100" dirty="0">
+                          <a:latin typeface="Arial Nova" panose="020B0504020202020204" pitchFamily="34" charset="0"/>
+                        </a:rPr>
+                        <a:t> </a:t>
+                      </a:r>
+                      <a:r>
+                        <a:rPr sz="1100" dirty="0" err="1">
+                          <a:latin typeface="Arial Nova" panose="020B0504020202020204" pitchFamily="34" charset="0"/>
+                        </a:rPr>
+                        <a:t>ronda</a:t>
+                      </a:r>
+                      <a:r>
+                        <a:rPr sz="1100" dirty="0">
+                          <a:latin typeface="Arial Nova" panose="020B0504020202020204" pitchFamily="34" charset="0"/>
+                        </a:rPr>
+                        <a:t> de </a:t>
+                      </a:r>
+                      <a:r>
+                        <a:rPr sz="1100" dirty="0" err="1">
+                          <a:latin typeface="Arial Nova" panose="020B0504020202020204" pitchFamily="34" charset="0"/>
+                        </a:rPr>
+                        <a:t>etiquetado</a:t>
+                      </a:r>
+                      <a:r>
+                        <a:rPr sz="1100" dirty="0">
+                          <a:latin typeface="Arial Nova" panose="020B0504020202020204" pitchFamily="34" charset="0"/>
+                        </a:rPr>
+                        <a:t> </a:t>
+                      </a:r>
+                      <a:r>
+                        <a:rPr sz="1100" dirty="0" err="1">
+                          <a:latin typeface="Arial Nova" panose="020B0504020202020204" pitchFamily="34" charset="0"/>
+                        </a:rPr>
+                        <a:t>por</a:t>
+                      </a:r>
+                      <a:r>
+                        <a:rPr sz="1100" dirty="0">
+                          <a:latin typeface="Arial Nova" panose="020B0504020202020204" pitchFamily="34" charset="0"/>
+                        </a:rPr>
+                        <a:t> </a:t>
+                      </a:r>
+                      <a:r>
+                        <a:rPr sz="1100" dirty="0" err="1">
+                          <a:latin typeface="Arial Nova" panose="020B0504020202020204" pitchFamily="34" charset="0"/>
+                        </a:rPr>
+                        <a:t>debajo</a:t>
+                      </a:r>
+                      <a:r>
+                        <a:rPr sz="1100" dirty="0">
+                          <a:latin typeface="Arial Nova" panose="020B0504020202020204" pitchFamily="34" charset="0"/>
+                        </a:rPr>
+                        <a:t> de 0,80 (umbral de la </a:t>
+                      </a:r>
+                      <a:r>
+                        <a:rPr sz="1100" dirty="0" err="1">
+                          <a:latin typeface="Arial Nova" panose="020B0504020202020204" pitchFamily="34" charset="0"/>
+                        </a:rPr>
+                        <a:t>rúbrica</a:t>
+                      </a:r>
+                      <a:r>
+                        <a:rPr sz="1100" dirty="0">
+                          <a:latin typeface="Arial Nova" panose="020B0504020202020204" pitchFamily="34" charset="0"/>
+                        </a:rPr>
+                        <a:t>) al 21 de </a:t>
+                      </a:r>
+                      <a:r>
+                        <a:rPr sz="1100" dirty="0" err="1">
+                          <a:latin typeface="Arial Nova" panose="020B0504020202020204" pitchFamily="34" charset="0"/>
+                        </a:rPr>
+                        <a:t>noviembre</a:t>
+                      </a:r>
+                      <a:endParaRPr sz="1100" dirty="0">
+                        <a:latin typeface="Arial Nova" panose="020B0504020202020204" pitchFamily="34" charset="0"/>
+                      </a:endParaRPr>
                     </a:p>
                   </a:txBody>
                   <a:tcPr marL="64008" marR="64008" marT="64008" marB="64008" anchor="ctr">
@@ -23244,7 +22545,7 @@
                     <a:lstStyle/>
                     <a:p>
                       <a:r>
-                        <a:rPr sz="1200">
+                        <a:rPr sz="1100">
                           <a:latin typeface="Arial Nova" panose="020B0504020202020204" pitchFamily="34" charset="0"/>
                         </a:rPr>
                         <a:t>Equipo completo</a:t>
@@ -23306,7 +22607,7 @@
                     <a:lstStyle/>
                     <a:p>
                       <a:r>
-                        <a:rPr sz="1200">
+                        <a:rPr sz="1100">
                           <a:latin typeface="Arial Nova" panose="020B0504020202020204" pitchFamily="34" charset="0"/>
                         </a:rPr>
                         <a:t>2</a:t>
@@ -23361,162 +22662,162 @@
                     <a:lstStyle/>
                     <a:p>
                       <a:r>
-                        <a:rPr sz="1200" dirty="0">
+                        <a:rPr sz="1100" dirty="0">
                           <a:latin typeface="Arial Nova" panose="020B0504020202020204" pitchFamily="34" charset="0"/>
                         </a:rPr>
                         <a:t>Los embeddings no </a:t>
                       </a:r>
                       <a:r>
-                        <a:rPr sz="1200" dirty="0" err="1">
+                        <a:rPr sz="1100" dirty="0" err="1">
                           <a:latin typeface="Arial Nova" panose="020B0504020202020204" pitchFamily="34" charset="0"/>
                         </a:rPr>
                         <a:t>filtran</a:t>
                       </a:r>
                       <a:r>
-                        <a:rPr sz="1200" dirty="0">
+                        <a:rPr sz="1100" dirty="0">
                           <a:latin typeface="Arial Nova" panose="020B0504020202020204" pitchFamily="34" charset="0"/>
                         </a:rPr>
                         <a:t> </a:t>
                       </a:r>
                       <a:r>
-                        <a:rPr sz="1200" dirty="0" err="1">
+                        <a:rPr sz="1100" dirty="0" err="1">
                           <a:latin typeface="Arial Nova" panose="020B0504020202020204" pitchFamily="34" charset="0"/>
                         </a:rPr>
                         <a:t>atributos</a:t>
                       </a:r>
                       <a:r>
-                        <a:rPr sz="1200" dirty="0">
+                        <a:rPr sz="1100" dirty="0">
                           <a:latin typeface="Arial Nova" panose="020B0504020202020204" pitchFamily="34" charset="0"/>
                         </a:rPr>
                         <a:t> </a:t>
                       </a:r>
                       <a:r>
-                        <a:rPr sz="1200" dirty="0" err="1">
+                        <a:rPr sz="1100" dirty="0" err="1">
                           <a:latin typeface="Arial Nova" panose="020B0504020202020204" pitchFamily="34" charset="0"/>
                         </a:rPr>
                         <a:t>estructurados</a:t>
                       </a:r>
                       <a:r>
-                        <a:rPr sz="1200" dirty="0">
+                        <a:rPr sz="1100" dirty="0">
                           <a:latin typeface="Arial Nova" panose="020B0504020202020204" pitchFamily="34" charset="0"/>
                         </a:rPr>
                         <a:t> (</a:t>
                       </a:r>
                       <a:r>
-                        <a:rPr sz="1200" dirty="0" err="1">
+                        <a:rPr sz="1100" dirty="0" err="1">
                           <a:latin typeface="Arial Nova" panose="020B0504020202020204" pitchFamily="34" charset="0"/>
                         </a:rPr>
                         <a:t>talla</a:t>
                       </a:r>
                       <a:r>
-                        <a:rPr sz="1200" dirty="0">
+                        <a:rPr sz="1100" dirty="0">
                           <a:latin typeface="Arial Nova" panose="020B0504020202020204" pitchFamily="34" charset="0"/>
                         </a:rPr>
                         <a:t>, </a:t>
                       </a:r>
                       <a:r>
-                        <a:rPr sz="1200" dirty="0" err="1">
+                        <a:rPr sz="1100" dirty="0" err="1">
                           <a:latin typeface="Arial Nova" panose="020B0504020202020204" pitchFamily="34" charset="0"/>
                         </a:rPr>
                         <a:t>precio</a:t>
                       </a:r>
                       <a:r>
-                        <a:rPr sz="1200" dirty="0">
+                        <a:rPr sz="1100" dirty="0">
                           <a:latin typeface="Arial Nova" panose="020B0504020202020204" pitchFamily="34" charset="0"/>
                         </a:rPr>
                         <a:t>, </a:t>
                       </a:r>
                       <a:r>
-                        <a:rPr sz="1200" dirty="0" err="1">
+                        <a:rPr sz="1100" dirty="0" err="1">
                           <a:latin typeface="Arial Nova" panose="020B0504020202020204" pitchFamily="34" charset="0"/>
                         </a:rPr>
                         <a:t>marca</a:t>
                       </a:r>
                       <a:r>
-                        <a:rPr sz="1200" dirty="0">
+                        <a:rPr sz="1100" dirty="0">
                           <a:latin typeface="Arial Nova" panose="020B0504020202020204" pitchFamily="34" charset="0"/>
                         </a:rPr>
                         <a:t>) — HR@3 </a:t>
                       </a:r>
                       <a:r>
-                        <a:rPr sz="1200" dirty="0" err="1">
+                        <a:rPr sz="1100" dirty="0" err="1">
                           <a:latin typeface="Arial Nova" panose="020B0504020202020204" pitchFamily="34" charset="0"/>
                         </a:rPr>
                         <a:t>cae</a:t>
                       </a:r>
                       <a:r>
-                        <a:rPr sz="1200" dirty="0">
+                        <a:rPr sz="1100" dirty="0">
                           <a:latin typeface="Arial Nova" panose="020B0504020202020204" pitchFamily="34" charset="0"/>
                         </a:rPr>
                         <a:t> a 20% </a:t>
                       </a:r>
                       <a:r>
-                        <a:rPr sz="1200" dirty="0" err="1">
+                        <a:rPr sz="1100" dirty="0" err="1">
                           <a:latin typeface="Arial Nova" panose="020B0504020202020204" pitchFamily="34" charset="0"/>
                         </a:rPr>
                         <a:t>en</a:t>
                       </a:r>
                       <a:r>
-                        <a:rPr sz="1200" dirty="0">
+                        <a:rPr sz="1100" dirty="0">
                           <a:latin typeface="Arial Nova" panose="020B0504020202020204" pitchFamily="34" charset="0"/>
                         </a:rPr>
                         <a:t> ese </a:t>
                       </a:r>
                       <a:r>
-                        <a:rPr sz="1200" dirty="0" err="1">
+                        <a:rPr sz="1100" dirty="0" err="1">
                           <a:latin typeface="Arial Nova" panose="020B0504020202020204" pitchFamily="34" charset="0"/>
                         </a:rPr>
                         <a:t>segmento</a:t>
                       </a:r>
                       <a:r>
-                        <a:rPr sz="1200" dirty="0">
+                        <a:rPr sz="1100" dirty="0">
                           <a:latin typeface="Arial Nova" panose="020B0504020202020204" pitchFamily="34" charset="0"/>
                         </a:rPr>
                         <a:t>, el </a:t>
                       </a:r>
                       <a:r>
-                        <a:rPr sz="1200" dirty="0" err="1">
+                        <a:rPr sz="1100" dirty="0" err="1">
                           <a:latin typeface="Arial Nova" panose="020B0504020202020204" pitchFamily="34" charset="0"/>
                         </a:rPr>
                         <a:t>más</a:t>
                       </a:r>
                       <a:r>
-                        <a:rPr sz="1200" dirty="0">
+                        <a:rPr sz="1100" dirty="0">
                           <a:latin typeface="Arial Nova" panose="020B0504020202020204" pitchFamily="34" charset="0"/>
                         </a:rPr>
                         <a:t> </a:t>
                       </a:r>
                       <a:r>
-                        <a:rPr sz="1200" dirty="0" err="1">
+                        <a:rPr sz="1100" dirty="0" err="1">
                           <a:latin typeface="Arial Nova" panose="020B0504020202020204" pitchFamily="34" charset="0"/>
                         </a:rPr>
                         <a:t>débil</a:t>
                       </a:r>
                       <a:r>
-                        <a:rPr sz="1200" dirty="0">
+                        <a:rPr sz="1100" dirty="0">
                           <a:latin typeface="Arial Nova" panose="020B0504020202020204" pitchFamily="34" charset="0"/>
                         </a:rPr>
                         <a:t> de </a:t>
                       </a:r>
                       <a:r>
-                        <a:rPr sz="1200" dirty="0" err="1">
+                        <a:rPr sz="1100" dirty="0" err="1">
                           <a:latin typeface="Arial Nova" panose="020B0504020202020204" pitchFamily="34" charset="0"/>
                         </a:rPr>
                         <a:t>los</a:t>
                       </a:r>
                       <a:r>
-                        <a:rPr sz="1200" dirty="0">
+                        <a:rPr sz="1100" dirty="0">
                           <a:latin typeface="Arial Nova" panose="020B0504020202020204" pitchFamily="34" charset="0"/>
                         </a:rPr>
                         <a:t> </a:t>
                       </a:r>
                       <a:r>
-                        <a:rPr sz="1200" dirty="0" err="1">
+                        <a:rPr sz="1100" dirty="0" err="1">
                           <a:latin typeface="Arial Nova" panose="020B0504020202020204" pitchFamily="34" charset="0"/>
                         </a:rPr>
                         <a:t>tres</a:t>
                       </a:r>
-                      <a:endParaRPr sz="1200" dirty="0">
+                      <a:endParaRPr sz="1100" dirty="0">
                         <a:latin typeface="Arial Nova" panose="020B0504020202020204" pitchFamily="34" charset="0"/>
                       </a:endParaRPr>
                     </a:p>
@@ -23569,7 +22870,7 @@
                     <a:lstStyle/>
                     <a:p>
                       <a:r>
-                        <a:rPr sz="1200">
+                        <a:rPr sz="1100">
                           <a:latin typeface="Arial Nova" panose="020B0504020202020204" pitchFamily="34" charset="0"/>
                         </a:rPr>
                         <a:t>Modelo</a:t>
@@ -23624,7 +22925,7 @@
                     <a:lstStyle/>
                     <a:p>
                       <a:r>
-                        <a:rPr sz="1200" dirty="0">
+                        <a:rPr sz="1100" dirty="0">
                           <a:latin typeface="Arial Nova" panose="020B0504020202020204" pitchFamily="34" charset="0"/>
                         </a:rPr>
                         <a:t>Alta</a:t>
@@ -23679,7 +22980,7 @@
                     <a:lstStyle/>
                     <a:p>
                       <a:r>
-                        <a:rPr sz="1200" dirty="0">
+                        <a:rPr sz="1100" dirty="0">
                           <a:latin typeface="Arial Nova" panose="020B0504020202020204" pitchFamily="34" charset="0"/>
                         </a:rPr>
                         <a:t>Alto</a:t>
@@ -23734,96 +23035,96 @@
                     <a:lstStyle/>
                     <a:p>
                       <a:r>
-                        <a:rPr sz="1200" dirty="0" err="1">
+                        <a:rPr sz="1100" dirty="0" err="1">
                           <a:latin typeface="Arial Nova" panose="020B0504020202020204" pitchFamily="34" charset="0"/>
                         </a:rPr>
                         <a:t>Diseñar</a:t>
                       </a:r>
                       <a:r>
-                        <a:rPr sz="1200" dirty="0">
+                        <a:rPr sz="1100" dirty="0">
                           <a:latin typeface="Arial Nova" panose="020B0504020202020204" pitchFamily="34" charset="0"/>
                         </a:rPr>
                         <a:t> un </a:t>
                       </a:r>
                       <a:r>
-                        <a:rPr sz="1200" dirty="0" err="1">
+                        <a:rPr sz="1100" dirty="0" err="1">
                           <a:latin typeface="Arial Nova" panose="020B0504020202020204" pitchFamily="34" charset="0"/>
                         </a:rPr>
                         <a:t>filtro</a:t>
                       </a:r>
                       <a:r>
-                        <a:rPr sz="1200" dirty="0">
+                        <a:rPr sz="1100" dirty="0">
                           <a:latin typeface="Arial Nova" panose="020B0504020202020204" pitchFamily="34" charset="0"/>
                         </a:rPr>
                         <a:t> </a:t>
                       </a:r>
                       <a:r>
-                        <a:rPr sz="1200" dirty="0" err="1">
+                        <a:rPr sz="1100" dirty="0" err="1">
                           <a:latin typeface="Arial Nova" panose="020B0504020202020204" pitchFamily="34" charset="0"/>
                         </a:rPr>
                         <a:t>híbrido</a:t>
                       </a:r>
                       <a:r>
-                        <a:rPr sz="1200" dirty="0">
+                        <a:rPr sz="1100" dirty="0">
                           <a:latin typeface="Arial Nova" panose="020B0504020202020204" pitchFamily="34" charset="0"/>
                         </a:rPr>
                         <a:t> (metadata </a:t>
                       </a:r>
                       <a:r>
-                        <a:rPr sz="1200" dirty="0" err="1">
+                        <a:rPr sz="1100" dirty="0" err="1">
                           <a:latin typeface="Arial Nova" panose="020B0504020202020204" pitchFamily="34" charset="0"/>
                         </a:rPr>
                         <a:t>estructurada</a:t>
                       </a:r>
                       <a:r>
-                        <a:rPr sz="1200" dirty="0">
+                        <a:rPr sz="1100" dirty="0">
                           <a:latin typeface="Arial Nova" panose="020B0504020202020204" pitchFamily="34" charset="0"/>
                         </a:rPr>
                         <a:t> + embeddings) para el </a:t>
                       </a:r>
                       <a:r>
-                        <a:rPr sz="1200" dirty="0" err="1">
+                        <a:rPr sz="1100" dirty="0" err="1">
                           <a:latin typeface="Arial Nova" panose="020B0504020202020204" pitchFamily="34" charset="0"/>
                         </a:rPr>
                         <a:t>prototipo</a:t>
                       </a:r>
                       <a:r>
-                        <a:rPr sz="1200" dirty="0">
+                        <a:rPr sz="1100" dirty="0">
                           <a:latin typeface="Arial Nova" panose="020B0504020202020204" pitchFamily="34" charset="0"/>
                         </a:rPr>
                         <a:t> del 21-nov; </a:t>
                       </a:r>
                       <a:r>
-                        <a:rPr sz="1200" dirty="0" err="1">
+                        <a:rPr sz="1100" dirty="0" err="1">
                           <a:latin typeface="Arial Nova" panose="020B0504020202020204" pitchFamily="34" charset="0"/>
                         </a:rPr>
                         <a:t>mientras</a:t>
                       </a:r>
                       <a:r>
-                        <a:rPr sz="1200" dirty="0">
+                        <a:rPr sz="1100" dirty="0">
                           <a:latin typeface="Arial Nova" panose="020B0504020202020204" pitchFamily="34" charset="0"/>
                         </a:rPr>
                         <a:t> tanto, </a:t>
                       </a:r>
                       <a:r>
-                        <a:rPr sz="1200" dirty="0" err="1">
+                        <a:rPr sz="1100" dirty="0" err="1">
                           <a:latin typeface="Arial Nova" panose="020B0504020202020204" pitchFamily="34" charset="0"/>
                         </a:rPr>
                         <a:t>declarar</a:t>
                       </a:r>
                       <a:r>
-                        <a:rPr sz="1200" dirty="0">
+                        <a:rPr sz="1100" dirty="0">
                           <a:latin typeface="Arial Nova" panose="020B0504020202020204" pitchFamily="34" charset="0"/>
                         </a:rPr>
                         <a:t> la </a:t>
                       </a:r>
                       <a:r>
-                        <a:rPr sz="1200" dirty="0" err="1">
+                        <a:rPr sz="1100" dirty="0" err="1">
                           <a:latin typeface="Arial Nova" panose="020B0504020202020204" pitchFamily="34" charset="0"/>
                         </a:rPr>
                         <a:t>limitación</a:t>
                       </a:r>
-                      <a:endParaRPr sz="1200" dirty="0">
+                      <a:endParaRPr sz="1100" dirty="0">
                         <a:latin typeface="Arial Nova" panose="020B0504020202020204" pitchFamily="34" charset="0"/>
                       </a:endParaRPr>
                     </a:p>
@@ -23876,92 +23177,11 @@
                     <a:lstStyle/>
                     <a:p>
                       <a:r>
-                        <a:rPr sz="1200" dirty="0">
+                        <a:rPr sz="1100" dirty="0">
                           <a:latin typeface="Arial Nova" panose="020B0504020202020204" pitchFamily="34" charset="0"/>
                         </a:rPr>
-                        <a:t>Más del 30% de las </a:t>
-                      </a:r>
-                      <a:r>
-                        <a:rPr sz="1200" dirty="0" err="1">
-                          <a:latin typeface="Arial Nova" panose="020B0504020202020204" pitchFamily="34" charset="0"/>
-                        </a:rPr>
-                        <a:t>quejas</a:t>
-                      </a:r>
-                      <a:r>
-                        <a:rPr sz="1200" dirty="0">
-                          <a:latin typeface="Arial Nova" panose="020B0504020202020204" pitchFamily="34" charset="0"/>
-                        </a:rPr>
-                        <a:t> de </a:t>
-                      </a:r>
-                      <a:r>
-                        <a:rPr sz="1200" dirty="0" err="1">
-                          <a:latin typeface="Arial Nova" panose="020B0504020202020204" pitchFamily="34" charset="0"/>
-                        </a:rPr>
-                        <a:t>usuarios</a:t>
-                      </a:r>
-                      <a:r>
-                        <a:rPr sz="1200" dirty="0">
-                          <a:latin typeface="Arial Nova" panose="020B0504020202020204" pitchFamily="34" charset="0"/>
-                        </a:rPr>
-                        <a:t> de </a:t>
-                      </a:r>
-                      <a:r>
-                        <a:rPr sz="1200" dirty="0" err="1">
-                          <a:latin typeface="Arial Nova" panose="020B0504020202020204" pitchFamily="34" charset="0"/>
-                        </a:rPr>
-                        <a:t>prueba</a:t>
-                      </a:r>
-                      <a:r>
-                        <a:rPr sz="1200" dirty="0">
-                          <a:latin typeface="Arial Nova" panose="020B0504020202020204" pitchFamily="34" charset="0"/>
-                        </a:rPr>
-                        <a:t> son </a:t>
-                      </a:r>
-                      <a:r>
-                        <a:rPr sz="1200" dirty="0" err="1">
-                          <a:latin typeface="Arial Nova" panose="020B0504020202020204" pitchFamily="34" charset="0"/>
-                        </a:rPr>
-                        <a:t>por</a:t>
-                      </a:r>
-                      <a:r>
-                        <a:rPr sz="1200" dirty="0">
-                          <a:latin typeface="Arial Nova" panose="020B0504020202020204" pitchFamily="34" charset="0"/>
-                        </a:rPr>
-                        <a:t> </a:t>
-                      </a:r>
-                      <a:r>
-                        <a:rPr sz="1200" dirty="0" err="1">
-                          <a:latin typeface="Arial Nova" panose="020B0504020202020204" pitchFamily="34" charset="0"/>
-                        </a:rPr>
-                        <a:t>talla</a:t>
-                      </a:r>
-                      <a:r>
-                        <a:rPr sz="1200" dirty="0">
-                          <a:latin typeface="Arial Nova" panose="020B0504020202020204" pitchFamily="34" charset="0"/>
-                        </a:rPr>
-                        <a:t>/</a:t>
-                      </a:r>
-                      <a:r>
-                        <a:rPr sz="1200" dirty="0" err="1">
-                          <a:latin typeface="Arial Nova" panose="020B0504020202020204" pitchFamily="34" charset="0"/>
-                        </a:rPr>
-                        <a:t>precio</a:t>
-                      </a:r>
-                      <a:r>
-                        <a:rPr sz="1200" dirty="0">
-                          <a:latin typeface="Arial Nova" panose="020B0504020202020204" pitchFamily="34" charset="0"/>
-                        </a:rPr>
-                        <a:t> no </a:t>
-                      </a:r>
-                      <a:r>
-                        <a:rPr sz="1200" dirty="0" err="1">
-                          <a:latin typeface="Arial Nova" panose="020B0504020202020204" pitchFamily="34" charset="0"/>
-                        </a:rPr>
-                        <a:t>filtrado</a:t>
-                      </a:r>
-                      <a:endParaRPr sz="1200" dirty="0">
-                        <a:latin typeface="Arial Nova" panose="020B0504020202020204" pitchFamily="34" charset="0"/>
-                      </a:endParaRPr>
+                        <a:t>Más del 30% de las quejas de usuarios de prueba son por talla/precio no filtrado, medido al 21 de noviembre</a:t>
+                      </a:r>
                     </a:p>
                   </a:txBody>
                   <a:tcPr marL="64008" marR="64008" marT="64008" marB="64008" anchor="ctr">
@@ -24012,18 +23232,18 @@
                     <a:lstStyle/>
                     <a:p>
                       <a:r>
-                        <a:rPr sz="1200" dirty="0">
+                        <a:rPr sz="1100" dirty="0">
                           <a:latin typeface="Arial Nova" panose="020B0504020202020204" pitchFamily="34" charset="0"/>
                         </a:rPr>
                         <a:t>Equipo </a:t>
                       </a:r>
                       <a:r>
-                        <a:rPr sz="1200" dirty="0" err="1">
+                        <a:rPr sz="1100" dirty="0" err="1">
                           <a:latin typeface="Arial Nova" panose="020B0504020202020204" pitchFamily="34" charset="0"/>
                         </a:rPr>
                         <a:t>técnico</a:t>
                       </a:r>
-                      <a:endParaRPr sz="1200" dirty="0">
+                      <a:endParaRPr sz="1100" dirty="0">
                         <a:latin typeface="Arial Nova" panose="020B0504020202020204" pitchFamily="34" charset="0"/>
                       </a:endParaRPr>
                     </a:p>
@@ -24083,7 +23303,7 @@
                     <a:lstStyle/>
                     <a:p>
                       <a:r>
-                        <a:rPr sz="1200" dirty="0">
+                        <a:rPr sz="1100" dirty="0">
                           <a:latin typeface="Arial Nova" panose="020B0504020202020204" pitchFamily="34" charset="0"/>
                         </a:rPr>
                         <a:t>3</a:t>
@@ -24138,144 +23358,144 @@
                     <a:lstStyle/>
                     <a:p>
                       <a:r>
-                        <a:rPr sz="1200" dirty="0" err="1">
+                        <a:rPr sz="1100" dirty="0" err="1">
                           <a:latin typeface="Arial Nova" panose="020B0504020202020204" pitchFamily="34" charset="0"/>
                         </a:rPr>
                         <a:t>Consultas</a:t>
                       </a:r>
                       <a:r>
-                        <a:rPr sz="1200" dirty="0">
+                        <a:rPr sz="1100" dirty="0">
                           <a:latin typeface="Arial Nova" panose="020B0504020202020204" pitchFamily="34" charset="0"/>
                         </a:rPr>
                         <a:t> reales </a:t>
                       </a:r>
                       <a:r>
-                        <a:rPr sz="1200" dirty="0" err="1">
+                        <a:rPr sz="1100" dirty="0" err="1">
                           <a:latin typeface="Arial Nova" panose="020B0504020202020204" pitchFamily="34" charset="0"/>
                         </a:rPr>
                         <a:t>piden</a:t>
                       </a:r>
                       <a:r>
-                        <a:rPr sz="1200" dirty="0">
+                        <a:rPr sz="1100" dirty="0">
                           <a:latin typeface="Arial Nova" panose="020B0504020202020204" pitchFamily="34" charset="0"/>
                         </a:rPr>
                         <a:t> </a:t>
                       </a:r>
                       <a:r>
-                        <a:rPr sz="1200" dirty="0" err="1">
+                        <a:rPr sz="1100" dirty="0" err="1">
                           <a:latin typeface="Arial Nova" panose="020B0504020202020204" pitchFamily="34" charset="0"/>
                         </a:rPr>
                         <a:t>productos</a:t>
                       </a:r>
                       <a:r>
-                        <a:rPr sz="1200" dirty="0">
+                        <a:rPr sz="1100" dirty="0">
                           <a:latin typeface="Arial Nova" panose="020B0504020202020204" pitchFamily="34" charset="0"/>
                         </a:rPr>
                         <a:t> '</a:t>
                       </a:r>
                       <a:r>
-                        <a:rPr sz="1200" dirty="0" err="1">
+                        <a:rPr sz="1100" dirty="0" err="1">
                           <a:latin typeface="Arial Nova" panose="020B0504020202020204" pitchFamily="34" charset="0"/>
                         </a:rPr>
                         <a:t>réplica</a:t>
                       </a:r>
                       <a:r>
-                        <a:rPr sz="1200" dirty="0">
+                        <a:rPr sz="1100" dirty="0">
                           <a:latin typeface="Arial Nova" panose="020B0504020202020204" pitchFamily="34" charset="0"/>
                         </a:rPr>
                         <a:t>' (</a:t>
                       </a:r>
                       <a:r>
-                        <a:rPr sz="1200" dirty="0" err="1">
+                        <a:rPr sz="1100" dirty="0" err="1">
                           <a:latin typeface="Arial Nova" panose="020B0504020202020204" pitchFamily="34" charset="0"/>
                         </a:rPr>
                         <a:t>ej</a:t>
                       </a:r>
                       <a:r>
-                        <a:rPr sz="1200" dirty="0">
+                        <a:rPr sz="1100" dirty="0">
                           <a:latin typeface="Arial Nova" panose="020B0504020202020204" pitchFamily="34" charset="0"/>
                         </a:rPr>
                         <a:t>. 'polos </a:t>
                       </a:r>
                       <a:r>
-                        <a:rPr sz="1200" dirty="0" err="1">
+                        <a:rPr sz="1100" dirty="0" err="1">
                           <a:latin typeface="Arial Nova" panose="020B0504020202020204" pitchFamily="34" charset="0"/>
                         </a:rPr>
                         <a:t>réplica</a:t>
                       </a:r>
                       <a:r>
-                        <a:rPr sz="1200" dirty="0">
+                        <a:rPr sz="1100" dirty="0">
                           <a:latin typeface="Arial Nova" panose="020B0504020202020204" pitchFamily="34" charset="0"/>
                         </a:rPr>
                         <a:t> a1') — </a:t>
                       </a:r>
                       <a:r>
-                        <a:rPr sz="1200" dirty="0" err="1">
+                        <a:rPr sz="1100" dirty="0" err="1">
                           <a:latin typeface="Arial Nova" panose="020B0504020202020204" pitchFamily="34" charset="0"/>
                         </a:rPr>
                         <a:t>recomendar</a:t>
                       </a:r>
                       <a:r>
-                        <a:rPr sz="1200" dirty="0">
+                        <a:rPr sz="1100" dirty="0">
                           <a:latin typeface="Arial Nova" panose="020B0504020202020204" pitchFamily="34" charset="0"/>
                         </a:rPr>
                         <a:t> tiendas sin </a:t>
                       </a:r>
                       <a:r>
-                        <a:rPr sz="1200" dirty="0" err="1">
+                        <a:rPr sz="1100" dirty="0" err="1">
                           <a:latin typeface="Arial Nova" panose="020B0504020202020204" pitchFamily="34" charset="0"/>
                         </a:rPr>
                         <a:t>verificar</a:t>
                       </a:r>
                       <a:r>
-                        <a:rPr sz="1200" dirty="0">
+                        <a:rPr sz="1100" dirty="0">
                           <a:latin typeface="Arial Nova" panose="020B0504020202020204" pitchFamily="34" charset="0"/>
                         </a:rPr>
                         <a:t> </a:t>
                       </a:r>
                       <a:r>
-                        <a:rPr sz="1200" dirty="0" err="1">
+                        <a:rPr sz="1100" dirty="0" err="1">
                           <a:latin typeface="Arial Nova" panose="020B0504020202020204" pitchFamily="34" charset="0"/>
                         </a:rPr>
                         <a:t>puede</a:t>
                       </a:r>
                       <a:r>
-                        <a:rPr sz="1200" dirty="0">
+                        <a:rPr sz="1100" dirty="0">
                           <a:latin typeface="Arial Nova" panose="020B0504020202020204" pitchFamily="34" charset="0"/>
                         </a:rPr>
                         <a:t> </a:t>
                       </a:r>
                       <a:r>
-                        <a:rPr sz="1200" dirty="0" err="1">
+                        <a:rPr sz="1100" dirty="0" err="1">
                           <a:latin typeface="Arial Nova" panose="020B0504020202020204" pitchFamily="34" charset="0"/>
                         </a:rPr>
                         <a:t>facilitar</a:t>
                       </a:r>
                       <a:r>
-                        <a:rPr sz="1200" dirty="0">
+                        <a:rPr sz="1100" dirty="0">
                           <a:latin typeface="Arial Nova" panose="020B0504020202020204" pitchFamily="34" charset="0"/>
                         </a:rPr>
                         <a:t> la </a:t>
                       </a:r>
                       <a:r>
-                        <a:rPr sz="1200" dirty="0" err="1">
+                        <a:rPr sz="1100" dirty="0" err="1">
                           <a:latin typeface="Arial Nova" panose="020B0504020202020204" pitchFamily="34" charset="0"/>
                         </a:rPr>
                         <a:t>venta</a:t>
                       </a:r>
                       <a:r>
-                        <a:rPr sz="1200" dirty="0">
+                        <a:rPr sz="1100" dirty="0">
                           <a:latin typeface="Arial Nova" panose="020B0504020202020204" pitchFamily="34" charset="0"/>
                         </a:rPr>
                         <a:t> de </a:t>
                       </a:r>
                       <a:r>
-                        <a:rPr sz="1200" dirty="0" err="1">
+                        <a:rPr sz="1100" dirty="0" err="1">
                           <a:latin typeface="Arial Nova" panose="020B0504020202020204" pitchFamily="34" charset="0"/>
                         </a:rPr>
                         <a:t>falsificaciones</a:t>
                       </a:r>
-                      <a:endParaRPr sz="1200" dirty="0">
+                      <a:endParaRPr sz="1100" dirty="0">
                         <a:latin typeface="Arial Nova" panose="020B0504020202020204" pitchFamily="34" charset="0"/>
                       </a:endParaRPr>
                     </a:p>
@@ -24328,24 +23548,24 @@
                     <a:lstStyle/>
                     <a:p>
                       <a:r>
-                        <a:rPr sz="1200" dirty="0" err="1">
+                        <a:rPr sz="1100" dirty="0" err="1">
                           <a:latin typeface="Arial Nova" panose="020B0504020202020204" pitchFamily="34" charset="0"/>
                         </a:rPr>
                         <a:t>Ética</a:t>
                       </a:r>
                       <a:r>
-                        <a:rPr sz="1200" dirty="0">
+                        <a:rPr sz="1100" dirty="0">
                           <a:latin typeface="Arial Nova" panose="020B0504020202020204" pitchFamily="34" charset="0"/>
                         </a:rPr>
                         <a:t> o </a:t>
                       </a:r>
                       <a:r>
-                        <a:rPr sz="1200" dirty="0" err="1">
+                        <a:rPr sz="1100" dirty="0" err="1">
                           <a:latin typeface="Arial Nova" panose="020B0504020202020204" pitchFamily="34" charset="0"/>
                         </a:rPr>
                         <a:t>regulación</a:t>
                       </a:r>
-                      <a:endParaRPr sz="1200" dirty="0">
+                      <a:endParaRPr sz="1100" dirty="0">
                         <a:latin typeface="Arial Nova" panose="020B0504020202020204" pitchFamily="34" charset="0"/>
                       </a:endParaRPr>
                     </a:p>
@@ -24398,7 +23618,7 @@
                     <a:lstStyle/>
                     <a:p>
                       <a:r>
-                        <a:rPr sz="1200" dirty="0">
+                        <a:rPr sz="1100" dirty="0">
                           <a:latin typeface="Arial Nova" panose="020B0504020202020204" pitchFamily="34" charset="0"/>
                         </a:rPr>
                         <a:t>Media</a:t>
@@ -24453,7 +23673,7 @@
                     <a:lstStyle/>
                     <a:p>
                       <a:r>
-                        <a:rPr sz="1200" dirty="0">
+                        <a:rPr sz="1100" dirty="0">
                           <a:latin typeface="Arial Nova" panose="020B0504020202020204" pitchFamily="34" charset="0"/>
                         </a:rPr>
                         <a:t>Alto</a:t>
@@ -24508,250 +23728,10 @@
                     <a:lstStyle/>
                     <a:p>
                       <a:r>
-                        <a:rPr sz="1200" dirty="0">
+                        <a:rPr sz="1100" dirty="0">
                           <a:latin typeface="Arial Nova" panose="020B0504020202020204" pitchFamily="34" charset="0"/>
                         </a:rPr>
-                        <a:t>No </a:t>
-                      </a:r>
-                      <a:r>
-                        <a:rPr sz="1200" dirty="0" err="1">
-                          <a:latin typeface="Arial Nova" panose="020B0504020202020204" pitchFamily="34" charset="0"/>
-                        </a:rPr>
-                        <a:t>marcar</a:t>
-                      </a:r>
-                      <a:r>
-                        <a:rPr sz="1200" dirty="0">
-                          <a:latin typeface="Arial Nova" panose="020B0504020202020204" pitchFamily="34" charset="0"/>
-                        </a:rPr>
-                        <a:t> </a:t>
-                      </a:r>
-                      <a:r>
-                        <a:rPr sz="1200" dirty="0" err="1">
-                          <a:latin typeface="Arial Nova" panose="020B0504020202020204" pitchFamily="34" charset="0"/>
-                        </a:rPr>
-                        <a:t>como</a:t>
-                      </a:r>
-                      <a:r>
-                        <a:rPr sz="1200" dirty="0">
-                          <a:latin typeface="Arial Nova" panose="020B0504020202020204" pitchFamily="34" charset="0"/>
-                        </a:rPr>
-                        <a:t> </a:t>
-                      </a:r>
-                      <a:r>
-                        <a:rPr sz="1200" dirty="0" err="1">
-                          <a:latin typeface="Arial Nova" panose="020B0504020202020204" pitchFamily="34" charset="0"/>
-                        </a:rPr>
-                        <a:t>relevante</a:t>
-                      </a:r>
-                      <a:r>
-                        <a:rPr sz="1200" dirty="0">
-                          <a:latin typeface="Arial Nova" panose="020B0504020202020204" pitchFamily="34" charset="0"/>
-                        </a:rPr>
-                        <a:t> </a:t>
-                      </a:r>
-                      <a:r>
-                        <a:rPr sz="1200" dirty="0" err="1">
-                          <a:latin typeface="Arial Nova" panose="020B0504020202020204" pitchFamily="34" charset="0"/>
-                        </a:rPr>
-                        <a:t>ninguna</a:t>
-                      </a:r>
-                      <a:r>
-                        <a:rPr sz="1200" dirty="0">
-                          <a:latin typeface="Arial Nova" panose="020B0504020202020204" pitchFamily="34" charset="0"/>
-                        </a:rPr>
-                        <a:t> tienda </a:t>
-                      </a:r>
-                      <a:r>
-                        <a:rPr sz="1200" dirty="0" err="1">
-                          <a:latin typeface="Arial Nova" panose="020B0504020202020204" pitchFamily="34" charset="0"/>
-                        </a:rPr>
-                        <a:t>en</a:t>
-                      </a:r>
-                      <a:r>
-                        <a:rPr sz="1200" dirty="0">
-                          <a:latin typeface="Arial Nova" panose="020B0504020202020204" pitchFamily="34" charset="0"/>
-                        </a:rPr>
-                        <a:t> </a:t>
-                      </a:r>
-                      <a:r>
-                        <a:rPr sz="1200" dirty="0" err="1">
-                          <a:latin typeface="Arial Nova" panose="020B0504020202020204" pitchFamily="34" charset="0"/>
-                        </a:rPr>
-                        <a:t>consultas</a:t>
-                      </a:r>
-                      <a:r>
-                        <a:rPr sz="1200" dirty="0">
-                          <a:latin typeface="Arial Nova" panose="020B0504020202020204" pitchFamily="34" charset="0"/>
-                        </a:rPr>
-                        <a:t> de </a:t>
-                      </a:r>
-                      <a:r>
-                        <a:rPr sz="1200" dirty="0" err="1">
-                          <a:latin typeface="Arial Nova" panose="020B0504020202020204" pitchFamily="34" charset="0"/>
-                        </a:rPr>
-                        <a:t>réplica</a:t>
-                      </a:r>
-                      <a:r>
-                        <a:rPr sz="1200" dirty="0">
-                          <a:latin typeface="Arial Nova" panose="020B0504020202020204" pitchFamily="34" charset="0"/>
-                        </a:rPr>
-                        <a:t> (</a:t>
-                      </a:r>
-                      <a:r>
-                        <a:rPr sz="1200" dirty="0" err="1">
-                          <a:latin typeface="Arial Nova" panose="020B0504020202020204" pitchFamily="34" charset="0"/>
-                        </a:rPr>
-                        <a:t>regla</a:t>
-                      </a:r>
-                      <a:r>
-                        <a:rPr sz="1200" dirty="0">
-                          <a:latin typeface="Arial Nova" panose="020B0504020202020204" pitchFamily="34" charset="0"/>
-                        </a:rPr>
-                        <a:t> </a:t>
-                      </a:r>
-                      <a:r>
-                        <a:rPr sz="1200" dirty="0" err="1">
-                          <a:latin typeface="Arial Nova" panose="020B0504020202020204" pitchFamily="34" charset="0"/>
-                        </a:rPr>
-                        <a:t>ya</a:t>
-                      </a:r>
-                      <a:r>
-                        <a:rPr sz="1200" dirty="0">
-                          <a:latin typeface="Arial Nova" panose="020B0504020202020204" pitchFamily="34" charset="0"/>
-                        </a:rPr>
-                        <a:t> </a:t>
-                      </a:r>
-                      <a:r>
-                        <a:rPr sz="1200" dirty="0" err="1">
-                          <a:latin typeface="Arial Nova" panose="020B0504020202020204" pitchFamily="34" charset="0"/>
-                        </a:rPr>
-                        <a:t>aplicada</a:t>
-                      </a:r>
-                      <a:r>
-                        <a:rPr sz="1200" dirty="0">
-                          <a:latin typeface="Arial Nova" panose="020B0504020202020204" pitchFamily="34" charset="0"/>
-                        </a:rPr>
-                        <a:t> </a:t>
-                      </a:r>
-                      <a:r>
-                        <a:rPr sz="1200" dirty="0" err="1">
-                          <a:latin typeface="Arial Nova" panose="020B0504020202020204" pitchFamily="34" charset="0"/>
-                        </a:rPr>
-                        <a:t>en</a:t>
-                      </a:r>
-                      <a:r>
-                        <a:rPr sz="1200" dirty="0">
-                          <a:latin typeface="Arial Nova" panose="020B0504020202020204" pitchFamily="34" charset="0"/>
-                        </a:rPr>
-                        <a:t> el </a:t>
-                      </a:r>
-                      <a:r>
-                        <a:rPr sz="1200" dirty="0" err="1">
-                          <a:latin typeface="Arial Nova" panose="020B0504020202020204" pitchFamily="34" charset="0"/>
-                        </a:rPr>
-                        <a:t>etiquetado</a:t>
-                      </a:r>
-                      <a:r>
-                        <a:rPr sz="1200" dirty="0">
-                          <a:latin typeface="Arial Nova" panose="020B0504020202020204" pitchFamily="34" charset="0"/>
-                        </a:rPr>
-                        <a:t>); </a:t>
-                      </a:r>
-                      <a:r>
-                        <a:rPr sz="1200" dirty="0" err="1">
-                          <a:latin typeface="Arial Nova" panose="020B0504020202020204" pitchFamily="34" charset="0"/>
-                        </a:rPr>
-                        <a:t>consultar</a:t>
-                      </a:r>
-                      <a:r>
-                        <a:rPr sz="1200" dirty="0">
-                          <a:latin typeface="Arial Nova" panose="020B0504020202020204" pitchFamily="34" charset="0"/>
-                        </a:rPr>
-                        <a:t> con el </a:t>
-                      </a:r>
-                      <a:r>
-                        <a:rPr sz="1200" dirty="0" err="1">
-                          <a:latin typeface="Arial Nova" panose="020B0504020202020204" pitchFamily="34" charset="0"/>
-                        </a:rPr>
-                        <a:t>asesor</a:t>
-                      </a:r>
-                      <a:r>
-                        <a:rPr sz="1200" dirty="0">
-                          <a:latin typeface="Arial Nova" panose="020B0504020202020204" pitchFamily="34" charset="0"/>
-                        </a:rPr>
-                        <a:t> </a:t>
-                      </a:r>
-                      <a:r>
-                        <a:rPr sz="1200" dirty="0" err="1">
-                          <a:latin typeface="Arial Nova" panose="020B0504020202020204" pitchFamily="34" charset="0"/>
-                        </a:rPr>
-                        <a:t>si</a:t>
-                      </a:r>
-                      <a:r>
-                        <a:rPr sz="1200" dirty="0">
-                          <a:latin typeface="Arial Nova" panose="020B0504020202020204" pitchFamily="34" charset="0"/>
-                        </a:rPr>
-                        <a:t> el </a:t>
-                      </a:r>
-                      <a:r>
-                        <a:rPr sz="1200" dirty="0" err="1">
-                          <a:latin typeface="Arial Nova" panose="020B0504020202020204" pitchFamily="34" charset="0"/>
-                        </a:rPr>
-                        <a:t>prototipo</a:t>
-                      </a:r>
-                      <a:r>
-                        <a:rPr sz="1200" dirty="0">
-                          <a:latin typeface="Arial Nova" panose="020B0504020202020204" pitchFamily="34" charset="0"/>
-                        </a:rPr>
-                        <a:t> </a:t>
-                      </a:r>
-                      <a:r>
-                        <a:rPr sz="1200" dirty="0" err="1">
-                          <a:latin typeface="Arial Nova" panose="020B0504020202020204" pitchFamily="34" charset="0"/>
-                        </a:rPr>
-                        <a:t>debe</a:t>
-                      </a:r>
-                      <a:r>
-                        <a:rPr sz="1200" dirty="0">
-                          <a:latin typeface="Arial Nova" panose="020B0504020202020204" pitchFamily="34" charset="0"/>
-                        </a:rPr>
-                        <a:t> </a:t>
-                      </a:r>
-                      <a:r>
-                        <a:rPr sz="1200" dirty="0" err="1">
-                          <a:latin typeface="Arial Nova" panose="020B0504020202020204" pitchFamily="34" charset="0"/>
-                        </a:rPr>
-                        <a:t>rechazar</a:t>
-                      </a:r>
-                      <a:r>
-                        <a:rPr sz="1200" dirty="0">
-                          <a:latin typeface="Arial Nova" panose="020B0504020202020204" pitchFamily="34" charset="0"/>
-                        </a:rPr>
-                        <a:t> </a:t>
-                      </a:r>
-                      <a:r>
-                        <a:rPr sz="1200" dirty="0" err="1">
-                          <a:latin typeface="Arial Nova" panose="020B0504020202020204" pitchFamily="34" charset="0"/>
-                        </a:rPr>
-                        <a:t>este</a:t>
-                      </a:r>
-                      <a:r>
-                        <a:rPr sz="1200" dirty="0">
-                          <a:latin typeface="Arial Nova" panose="020B0504020202020204" pitchFamily="34" charset="0"/>
-                        </a:rPr>
-                        <a:t> </a:t>
-                      </a:r>
-                      <a:r>
-                        <a:rPr sz="1200" dirty="0" err="1">
-                          <a:latin typeface="Arial Nova" panose="020B0504020202020204" pitchFamily="34" charset="0"/>
-                        </a:rPr>
-                        <a:t>tipo</a:t>
-                      </a:r>
-                      <a:r>
-                        <a:rPr sz="1200" dirty="0">
-                          <a:latin typeface="Arial Nova" panose="020B0504020202020204" pitchFamily="34" charset="0"/>
-                        </a:rPr>
-                        <a:t> de consulta</a:t>
+                        <a:t>Decisión de producto: el agente RECHAZA la consulta (no busca ni recomienda ninguna tienda) cuando detecta intención de réplica/falsificación — ya no es solo una regla de evaluación. Confirmar el criterio de detección con el asesor antes del 21 de noviembre.</a:t>
                       </a:r>
                     </a:p>
                   </a:txBody>
@@ -24803,108 +23783,12 @@
                     <a:lstStyle/>
                     <a:p>
                       <a:r>
-                        <a:rPr sz="1200" dirty="0" err="1">
+                        <a:rPr sz="1100" dirty="0" err="1">
                           <a:latin typeface="Arial Nova" panose="020B0504020202020204" pitchFamily="34" charset="0"/>
                         </a:rPr>
-                        <a:t>Consultas</a:t>
-                      </a:r>
-                      <a:r>
-                        <a:rPr sz="1200" dirty="0">
-                          <a:latin typeface="Arial Nova" panose="020B0504020202020204" pitchFamily="34" charset="0"/>
-                        </a:rPr>
-                        <a:t> de </a:t>
-                      </a:r>
-                      <a:r>
-                        <a:rPr sz="1200" dirty="0" err="1">
-                          <a:latin typeface="Arial Nova" panose="020B0504020202020204" pitchFamily="34" charset="0"/>
-                        </a:rPr>
-                        <a:t>réplica</a:t>
-                      </a:r>
-                      <a:r>
-                        <a:rPr sz="1200" dirty="0">
-                          <a:latin typeface="Arial Nova" panose="020B0504020202020204" pitchFamily="34" charset="0"/>
-                        </a:rPr>
-                        <a:t>/</a:t>
-                      </a:r>
-                      <a:r>
-                        <a:rPr sz="1200" dirty="0" err="1">
-                          <a:latin typeface="Arial Nova" panose="020B0504020202020204" pitchFamily="34" charset="0"/>
-                        </a:rPr>
-                        <a:t>marca</a:t>
-                      </a:r>
-                      <a:r>
-                        <a:rPr sz="1200" dirty="0">
-                          <a:latin typeface="Arial Nova" panose="020B0504020202020204" pitchFamily="34" charset="0"/>
-                        </a:rPr>
-                        <a:t> no </a:t>
-                      </a:r>
-                      <a:r>
-                        <a:rPr sz="1200" dirty="0" err="1">
-                          <a:latin typeface="Arial Nova" panose="020B0504020202020204" pitchFamily="34" charset="0"/>
-                        </a:rPr>
-                        <a:t>autorizada</a:t>
-                      </a:r>
-                      <a:r>
-                        <a:rPr sz="1200" dirty="0">
-                          <a:latin typeface="Arial Nova" panose="020B0504020202020204" pitchFamily="34" charset="0"/>
-                        </a:rPr>
-                        <a:t> </a:t>
-                      </a:r>
-                      <a:r>
-                        <a:rPr sz="1200" dirty="0" err="1">
-                          <a:latin typeface="Arial Nova" panose="020B0504020202020204" pitchFamily="34" charset="0"/>
-                        </a:rPr>
-                        <a:t>en</a:t>
-                      </a:r>
-                      <a:r>
-                        <a:rPr sz="1200" dirty="0">
-                          <a:latin typeface="Arial Nova" panose="020B0504020202020204" pitchFamily="34" charset="0"/>
-                        </a:rPr>
-                        <a:t> </a:t>
-                      </a:r>
-                      <a:r>
-                        <a:rPr sz="1200" dirty="0" err="1">
-                          <a:latin typeface="Arial Nova" panose="020B0504020202020204" pitchFamily="34" charset="0"/>
-                        </a:rPr>
-                        <a:t>más</a:t>
-                      </a:r>
-                      <a:r>
-                        <a:rPr sz="1200" dirty="0">
-                          <a:latin typeface="Arial Nova" panose="020B0504020202020204" pitchFamily="34" charset="0"/>
-                        </a:rPr>
-                        <a:t> del 5% de </a:t>
-                      </a:r>
-                      <a:r>
-                        <a:rPr sz="1200" dirty="0" err="1">
-                          <a:latin typeface="Arial Nova" panose="020B0504020202020204" pitchFamily="34" charset="0"/>
-                        </a:rPr>
-                        <a:t>una</a:t>
-                      </a:r>
-                      <a:r>
-                        <a:rPr sz="1200" dirty="0">
-                          <a:latin typeface="Arial Nova" panose="020B0504020202020204" pitchFamily="34" charset="0"/>
-                        </a:rPr>
-                        <a:t> </a:t>
-                      </a:r>
-                      <a:r>
-                        <a:rPr sz="1200" dirty="0" err="1">
-                          <a:latin typeface="Arial Nova" panose="020B0504020202020204" pitchFamily="34" charset="0"/>
-                        </a:rPr>
-                        <a:t>muestra</a:t>
-                      </a:r>
-                      <a:r>
-                        <a:rPr sz="1200" dirty="0">
-                          <a:latin typeface="Arial Nova" panose="020B0504020202020204" pitchFamily="34" charset="0"/>
-                        </a:rPr>
-                        <a:t> </a:t>
-                      </a:r>
-                      <a:r>
-                        <a:rPr sz="1200" dirty="0" err="1">
-                          <a:latin typeface="Arial Nova" panose="020B0504020202020204" pitchFamily="34" charset="0"/>
-                        </a:rPr>
-                        <a:t>ampliada</a:t>
-                      </a:r>
-                      <a:endParaRPr sz="1200" dirty="0">
+                        <a:t>Consultas de réplica/marca no autorizada en más del 5% de una muestra ampliada, medido al 21 de noviembre.</a:t>
+                      </a:r>
+                      <a:endParaRPr sz="1100" dirty="0">
                         <a:latin typeface="Arial Nova" panose="020B0504020202020204" pitchFamily="34" charset="0"/>
                       </a:endParaRPr>
                     </a:p>
@@ -24957,18 +23841,18 @@
                     <a:lstStyle/>
                     <a:p>
                       <a:r>
-                        <a:rPr sz="1200" dirty="0">
+                        <a:rPr sz="1100" dirty="0">
                           <a:latin typeface="Arial Nova" panose="020B0504020202020204" pitchFamily="34" charset="0"/>
                         </a:rPr>
                         <a:t>Francisco Meza / </a:t>
                       </a:r>
                       <a:r>
-                        <a:rPr sz="1200" dirty="0" err="1">
+                        <a:rPr sz="1100" dirty="0" err="1">
                           <a:latin typeface="Arial Nova" panose="020B0504020202020204" pitchFamily="34" charset="0"/>
                         </a:rPr>
                         <a:t>asesor</a:t>
                       </a:r>
-                      <a:endParaRPr sz="1200" dirty="0">
+                      <a:endParaRPr sz="1100" dirty="0">
                         <a:latin typeface="Arial Nova" panose="020B0504020202020204" pitchFamily="34" charset="0"/>
                       </a:endParaRPr>
                     </a:p>
@@ -25061,7 +23945,7 @@
         </p:nvSpPr>
         <p:spPr>
           <a:xfrm>
-            <a:off x="8762695" y="6400800"/>
+            <a:off x="9259257" y="6537960"/>
             <a:ext cx="2743200" cy="274320"/>
           </a:xfrm>
           <a:prstGeom prst="rect">
@@ -25078,7 +23962,7 @@
               <a:buNone/>
             </a:pPr>
             <a:r>
-              <a:rPr sz="1000">
+              <a:rPr sz="1000" dirty="0">
                 <a:solidFill>
                   <a:srgbClr val="666666"/>
                 </a:solidFill>

</xml_diff>

<commit_message>
Ajustes menores: ejemplo de Halloween en el chat, responsable del riesgo 2
Cambia el placeholder de busqueda en app.py a un ejemplo de disfraz, y
actualiza el responsable del riesgo 2 (talla/precio) de "Equipo tecnico"
a "Equipo completo" en el registro de riesgos de E5.
</commit_message>
<xml_diff>
--- a/E5_Equipo7_Portal_Gamarrino.pptx
+++ b/E5_Equipo7_Portal_Gamarrino.pptx
@@ -2038,7 +2038,7 @@
               <a:rPr sz="1300" b="1" u="sng" dirty="0">
                 <a:latin typeface="Arial Nova Light"/>
               </a:rPr>
-              <a:t>-AI (privado).</a:t>
+              <a:t>-AI</a:t>
             </a:r>
             <a:endParaRPr lang="es-PE" sz="1300" b="1" u="sng" noProof="0" dirty="0">
               <a:solidFill>
@@ -9961,7 +9961,7 @@
           <p:nvPr>
             <p:extLst>
               <p:ext uri="{D42A27DB-BD31-4B8C-83A1-F6EECF244321}">
-                <p14:modId xmlns:p14="http://schemas.microsoft.com/office/powerpoint/2010/main" val="3738698"/>
+                <p14:modId xmlns:p14="http://schemas.microsoft.com/office/powerpoint/2010/main" val="2719712624"/>
               </p:ext>
             </p:extLst>
           </p:nvPr>
@@ -10385,15 +10385,15 @@
                     <a:lstStyle/>
                     <a:p>
                       <a:r>
-                        <a:rPr sz="1400" dirty="0"/>
+                        <a:rPr sz="1400" b="1" dirty="0"/>
                         <a:t>No </a:t>
                       </a:r>
                       <a:r>
-                        <a:rPr sz="1400" dirty="0" err="1"/>
+                        <a:rPr sz="1400" b="1" dirty="0" err="1"/>
                         <a:t>hacer</a:t>
                       </a:r>
                       <a:r>
-                        <a:rPr sz="1400" dirty="0"/>
+                        <a:rPr sz="1400" b="1" dirty="0"/>
                         <a:t> nada</a:t>
                       </a:r>
                     </a:p>
@@ -10665,23 +10665,23 @@
                     <a:lstStyle/>
                     <a:p>
                       <a:r>
-                        <a:rPr sz="1400" dirty="0"/>
+                        <a:rPr sz="1400" b="1" dirty="0"/>
                         <a:t>Lo </a:t>
                       </a:r>
                       <a:r>
-                        <a:rPr sz="1400" dirty="0" err="1"/>
+                        <a:rPr sz="1400" b="1" dirty="0" err="1"/>
                         <a:t>que</a:t>
                       </a:r>
                       <a:r>
-                        <a:rPr sz="1400" dirty="0"/>
+                        <a:rPr sz="1400" b="1" dirty="0"/>
                         <a:t> se </a:t>
                       </a:r>
                       <a:r>
-                        <a:rPr sz="1400" dirty="0" err="1"/>
+                        <a:rPr sz="1400" b="1" dirty="0" err="1"/>
                         <a:t>hace</a:t>
                       </a:r>
                       <a:r>
-                        <a:rPr sz="1400" dirty="0"/>
+                        <a:rPr sz="1400" b="1" dirty="0"/>
                         <a:t> hoy</a:t>
                       </a:r>
                     </a:p>
@@ -10953,7 +10953,7 @@
                     <a:lstStyle/>
                     <a:p>
                       <a:r>
-                        <a:rPr sz="1400" dirty="0"/>
+                        <a:rPr sz="1400" b="1" dirty="0"/>
                         <a:t>Modelo simple</a:t>
                       </a:r>
                     </a:p>
@@ -11225,7 +11225,7 @@
                     <a:lstStyle/>
                     <a:p>
                       <a:r>
-                        <a:rPr sz="1400"/>
+                        <a:rPr sz="1400" b="1" dirty="0"/>
                         <a:t>Modelo v0</a:t>
                       </a:r>
                     </a:p>
@@ -11268,7 +11268,9 @@
                       <a:tailEnd type="none" w="med" len="med"/>
                     </a:lnB>
                     <a:solidFill>
-                      <a:srgbClr val="FFFFFF"/>
+                      <a:schemeClr val="bg2">
+                        <a:lumMod val="75000"/>
+                      </a:schemeClr>
                     </a:solidFill>
                   </a:tcPr>
                 </a:tc>
@@ -11278,7 +11280,7 @@
                     <a:lstStyle/>
                     <a:p>
                       <a:r>
-                        <a:rPr sz="1400"/>
+                        <a:rPr sz="1400" b="1" dirty="0"/>
                         <a:t>66,9% [61,9-71,4]</a:t>
                       </a:r>
                     </a:p>
@@ -11321,7 +11323,9 @@
                       <a:tailEnd type="none" w="med" len="med"/>
                     </a:lnB>
                     <a:solidFill>
-                      <a:srgbClr val="FFFFFF"/>
+                      <a:schemeClr val="bg2">
+                        <a:lumMod val="75000"/>
+                      </a:schemeClr>
                     </a:solidFill>
                   </a:tcPr>
                 </a:tc>
@@ -11331,8 +11335,24 @@
                     <a:lstStyle/>
                     <a:p>
                       <a:r>
-                        <a:rPr sz="1400"/>
-                        <a:t>Por medir (sin prototipo)</a:t>
+                        <a:rPr sz="1400" b="1" dirty="0"/>
+                        <a:t>Por </a:t>
+                      </a:r>
+                      <a:r>
+                        <a:rPr sz="1400" b="1" dirty="0" err="1"/>
+                        <a:t>medir</a:t>
+                      </a:r>
+                      <a:r>
+                        <a:rPr sz="1400" b="1" dirty="0"/>
+                        <a:t> (sin </a:t>
+                      </a:r>
+                      <a:r>
+                        <a:rPr sz="1400" b="1" dirty="0" err="1"/>
+                        <a:t>prototipo</a:t>
+                      </a:r>
+                      <a:r>
+                        <a:rPr sz="1400" b="1" dirty="0"/>
+                        <a:t>)</a:t>
                       </a:r>
                     </a:p>
                   </a:txBody>
@@ -11374,7 +11394,9 @@
                       <a:tailEnd type="none" w="med" len="med"/>
                     </a:lnB>
                     <a:solidFill>
-                      <a:srgbClr val="FFFFFF"/>
+                      <a:schemeClr val="bg2">
+                        <a:lumMod val="75000"/>
+                      </a:schemeClr>
                     </a:solidFill>
                   </a:tcPr>
                 </a:tc>
@@ -11384,7 +11406,7 @@
                     <a:lstStyle/>
                     <a:p>
                       <a:r>
-                        <a:rPr sz="1400" dirty="0"/>
+                        <a:rPr sz="1400" b="1" dirty="0"/>
                         <a:t>&lt;$0,01 / ~0,3-0,5s embed.</a:t>
                       </a:r>
                     </a:p>
@@ -11427,7 +11449,9 @@
                       <a:tailEnd type="none" w="med" len="med"/>
                     </a:lnB>
                     <a:solidFill>
-                      <a:srgbClr val="FFFFFF"/>
+                      <a:schemeClr val="bg2">
+                        <a:lumMod val="75000"/>
+                      </a:schemeClr>
                     </a:solidFill>
                   </a:tcPr>
                 </a:tc>
@@ -11437,7 +11461,7 @@
                     <a:lstStyle/>
                     <a:p>
                       <a:r>
-                        <a:rPr sz="1400" dirty="0"/>
+                        <a:rPr sz="1400" b="1" dirty="0"/>
                         <a:t>378 (280 dist.)</a:t>
                       </a:r>
                     </a:p>
@@ -11480,7 +11504,9 @@
                       <a:tailEnd type="none" w="med" len="med"/>
                     </a:lnB>
                     <a:solidFill>
-                      <a:srgbClr val="FFFFFF"/>
+                      <a:schemeClr val="bg2">
+                        <a:lumMod val="75000"/>
+                      </a:schemeClr>
                     </a:solidFill>
                   </a:tcPr>
                 </a:tc>
@@ -12538,7 +12564,7 @@
           <p:nvPr>
             <p:extLst>
               <p:ext uri="{D42A27DB-BD31-4B8C-83A1-F6EECF244321}">
-                <p14:modId xmlns:p14="http://schemas.microsoft.com/office/powerpoint/2010/main" val="1413163078"/>
+                <p14:modId xmlns:p14="http://schemas.microsoft.com/office/powerpoint/2010/main" val="3095252971"/>
               </p:ext>
             </p:extLst>
           </p:nvPr>
@@ -13263,37 +13289,37 @@
                     <a:lstStyle/>
                     <a:p>
                       <a:r>
-                        <a:rPr sz="1200" dirty="0" err="1">
+                        <a:rPr sz="1200" b="1" dirty="0" err="1">
                           <a:latin typeface="Arial Nova" panose="020B0504020202020204" pitchFamily="34" charset="0"/>
                         </a:rPr>
                         <a:t>Específica</a:t>
                       </a:r>
                       <a:r>
-                        <a:rPr sz="1200" dirty="0">
+                        <a:rPr sz="1200" b="1" dirty="0">
                           <a:latin typeface="Arial Nova" panose="020B0504020202020204" pitchFamily="34" charset="0"/>
                         </a:rPr>
                         <a:t> (</a:t>
                       </a:r>
                       <a:r>
-                        <a:rPr sz="1200" dirty="0" err="1">
+                        <a:rPr sz="1200" b="1" dirty="0" err="1">
                           <a:latin typeface="Arial Nova" panose="020B0504020202020204" pitchFamily="34" charset="0"/>
                         </a:rPr>
                         <a:t>una</a:t>
                       </a:r>
                       <a:r>
-                        <a:rPr sz="1200" dirty="0">
+                        <a:rPr sz="1200" b="1" dirty="0">
                           <a:latin typeface="Arial Nova" panose="020B0504020202020204" pitchFamily="34" charset="0"/>
                         </a:rPr>
                         <a:t> </a:t>
                       </a:r>
                       <a:r>
-                        <a:rPr sz="1200" dirty="0" err="1">
+                        <a:rPr sz="1200" b="1" dirty="0" err="1">
                           <a:latin typeface="Arial Nova" panose="020B0504020202020204" pitchFamily="34" charset="0"/>
                         </a:rPr>
                         <a:t>prenda</a:t>
                       </a:r>
                       <a:r>
-                        <a:rPr sz="1200" dirty="0">
+                        <a:rPr sz="1200" b="1" dirty="0">
                           <a:latin typeface="Arial Nova" panose="020B0504020202020204" pitchFamily="34" charset="0"/>
                         </a:rPr>
                         <a:t>)</a:t>
@@ -13575,11 +13601,26 @@
                     <a:lstStyle/>
                     <a:p>
                       <a:r>
-                        <a:rPr sz="1200">
+                        <a:rPr sz="1200" b="1" dirty="0" err="1">
                           <a:latin typeface="Arial Nova" panose="020B0504020202020204" pitchFamily="34" charset="0"/>
                         </a:rPr>
-                        <a:t>Ambigua o compuesta</a:t>
-                      </a:r>
+                        <a:t>Ambigua</a:t>
+                      </a:r>
+                      <a:r>
+                        <a:rPr sz="1200" b="1" dirty="0">
+                          <a:latin typeface="Arial Nova" panose="020B0504020202020204" pitchFamily="34" charset="0"/>
+                        </a:rPr>
+                        <a:t> o </a:t>
+                      </a:r>
+                      <a:r>
+                        <a:rPr sz="1200" b="1" dirty="0" err="1">
+                          <a:latin typeface="Arial Nova" panose="020B0504020202020204" pitchFamily="34" charset="0"/>
+                        </a:rPr>
+                        <a:t>compuesta</a:t>
+                      </a:r>
+                      <a:endParaRPr sz="1200" b="1" dirty="0">
+                        <a:latin typeface="Arial Nova" panose="020B0504020202020204" pitchFamily="34" charset="0"/>
+                      </a:endParaRPr>
                     </a:p>
                   </a:txBody>
                   <a:tcPr marL="64008" marR="64008" marT="64008" marB="64008" anchor="ctr">
@@ -13953,42 +13994,42 @@
                     <a:lstStyle/>
                     <a:p>
                       <a:r>
-                        <a:rPr sz="1200" dirty="0">
+                        <a:rPr sz="1200" b="1" dirty="0">
                           <a:latin typeface="Arial Nova" panose="020B0504020202020204" pitchFamily="34" charset="0"/>
                         </a:rPr>
                         <a:t>Con </a:t>
                       </a:r>
                       <a:r>
-                        <a:rPr sz="1200" dirty="0" err="1">
+                        <a:rPr sz="1200" b="1" dirty="0" err="1">
                           <a:latin typeface="Arial Nova" panose="020B0504020202020204" pitchFamily="34" charset="0"/>
                         </a:rPr>
                         <a:t>marca</a:t>
                       </a:r>
                       <a:r>
-                        <a:rPr sz="1200" dirty="0">
+                        <a:rPr sz="1200" b="1" dirty="0">
                           <a:latin typeface="Arial Nova" panose="020B0504020202020204" pitchFamily="34" charset="0"/>
                         </a:rPr>
                         <a:t>, </a:t>
                       </a:r>
                       <a:r>
-                        <a:rPr sz="1200" dirty="0" err="1">
+                        <a:rPr sz="1200" b="1" dirty="0" err="1">
                           <a:latin typeface="Arial Nova" panose="020B0504020202020204" pitchFamily="34" charset="0"/>
                         </a:rPr>
                         <a:t>talla</a:t>
                       </a:r>
                       <a:r>
-                        <a:rPr sz="1200" dirty="0">
+                        <a:rPr sz="1200" b="1" dirty="0">
                           <a:latin typeface="Arial Nova" panose="020B0504020202020204" pitchFamily="34" charset="0"/>
                         </a:rPr>
                         <a:t> o </a:t>
                       </a:r>
                       <a:r>
-                        <a:rPr sz="1200" dirty="0" err="1">
+                        <a:rPr sz="1200" b="1" dirty="0" err="1">
                           <a:latin typeface="Arial Nova" panose="020B0504020202020204" pitchFamily="34" charset="0"/>
                         </a:rPr>
                         <a:t>precio</a:t>
                       </a:r>
-                      <a:endParaRPr sz="1200" dirty="0">
+                      <a:endParaRPr sz="1200" b="1" dirty="0">
                         <a:latin typeface="Arial Nova" panose="020B0504020202020204" pitchFamily="34" charset="0"/>
                       </a:endParaRPr>
                     </a:p>
@@ -21303,7 +21344,7 @@
           <p:nvPr>
             <p:extLst>
               <p:ext uri="{D42A27DB-BD31-4B8C-83A1-F6EECF244321}">
-                <p14:modId xmlns:p14="http://schemas.microsoft.com/office/powerpoint/2010/main" val="3187042776"/>
+                <p14:modId xmlns:p14="http://schemas.microsoft.com/office/powerpoint/2010/main" val="3719528566"/>
               </p:ext>
             </p:extLst>
           </p:nvPr>
@@ -23238,10 +23279,10 @@
                         <a:t>Equipo </a:t>
                       </a:r>
                       <a:r>
-                        <a:rPr sz="1100" dirty="0" err="1">
+                        <a:rPr lang="es-MX" sz="1100" dirty="0">
                           <a:latin typeface="Arial Nova" panose="020B0504020202020204" pitchFamily="34" charset="0"/>
                         </a:rPr>
-                        <a:t>técnico</a:t>
+                        <a:t>completo</a:t>
                       </a:r>
                       <a:endParaRPr sz="1100" dirty="0">
                         <a:latin typeface="Arial Nova" panose="020B0504020202020204" pitchFamily="34" charset="0"/>

</xml_diff>